<commit_message>
Update trait profile investigation figures and methods
</commit_message>
<xml_diff>
--- a/trait-visualization/trait-profile-investigation/trait_profile_investigation_figures.pptx
+++ b/trait-visualization/trait-profile-investigation/trait_profile_investigation_figures.pptx
@@ -2,22 +2,23 @@
 <file path=ppt/presentation.xml><?xml version="1.0" encoding="utf-8"?>
 <p:presentation xmlns:p="http://schemas.openxmlformats.org/presentationml/2006/main">
   <p:sldMasterIdLst>
-    <p:sldMasterId xmlns:r="http://schemas.openxmlformats.org/officeDocument/2006/relationships" id="2147483648" r:id="Rddab14aee09f4f5d"/>
+    <p:sldMasterId xmlns:r="http://schemas.openxmlformats.org/officeDocument/2006/relationships" id="2147483648" r:id="Rdc36e95add524681"/>
   </p:sldMasterIdLst>
   <p:notesMasterIdLst>
-    <p:notesMasterId xmlns:r="http://schemas.openxmlformats.org/officeDocument/2006/relationships" r:id="Rcf7196ffdb9e4001"/>
+    <p:notesMasterId xmlns:r="http://schemas.openxmlformats.org/officeDocument/2006/relationships" r:id="Rbc5dfe8ce93e4882"/>
   </p:notesMasterIdLst>
   <p:sldIdLst>
-    <p:sldId xmlns:r="http://schemas.openxmlformats.org/officeDocument/2006/relationships" id="256" r:id="R01a40b6d8abe42f5"/>
-    <p:sldId xmlns:r="http://schemas.openxmlformats.org/officeDocument/2006/relationships" id="257" r:id="R32828fcb05994c96"/>
-    <p:sldId xmlns:r="http://schemas.openxmlformats.org/officeDocument/2006/relationships" id="258" r:id="Rc2bfb4bb04e74dee"/>
-    <p:sldId xmlns:r="http://schemas.openxmlformats.org/officeDocument/2006/relationships" id="259" r:id="Rc25ab309963b4643"/>
-    <p:sldId xmlns:r="http://schemas.openxmlformats.org/officeDocument/2006/relationships" id="260" r:id="R2061f36eb0774ba0"/>
-    <p:sldId xmlns:r="http://schemas.openxmlformats.org/officeDocument/2006/relationships" id="261" r:id="Re51a83bbe6034696"/>
-    <p:sldId xmlns:r="http://schemas.openxmlformats.org/officeDocument/2006/relationships" id="262" r:id="R6abdf4acbebf4cdf"/>
-    <p:sldId xmlns:r="http://schemas.openxmlformats.org/officeDocument/2006/relationships" id="263" r:id="Ra53e68d3de264803"/>
-    <p:sldId xmlns:r="http://schemas.openxmlformats.org/officeDocument/2006/relationships" id="264" r:id="Rd216c41292fd44e6"/>
-    <p:sldId xmlns:r="http://schemas.openxmlformats.org/officeDocument/2006/relationships" id="265" r:id="Rac595b1fe13946aa"/>
+    <p:sldId xmlns:r="http://schemas.openxmlformats.org/officeDocument/2006/relationships" id="256" r:id="Ra064f2cd4e094acb"/>
+    <p:sldId xmlns:r="http://schemas.openxmlformats.org/officeDocument/2006/relationships" id="257" r:id="R2764ec9049dd4200"/>
+    <p:sldId xmlns:r="http://schemas.openxmlformats.org/officeDocument/2006/relationships" id="258" r:id="Ra32b1c636f6042c6"/>
+    <p:sldId xmlns:r="http://schemas.openxmlformats.org/officeDocument/2006/relationships" id="259" r:id="R03cd14c4059845e0"/>
+    <p:sldId xmlns:r="http://schemas.openxmlformats.org/officeDocument/2006/relationships" id="260" r:id="R20d339ecef8247f5"/>
+    <p:sldId xmlns:r="http://schemas.openxmlformats.org/officeDocument/2006/relationships" id="261" r:id="R2696e3e83b134065"/>
+    <p:sldId xmlns:r="http://schemas.openxmlformats.org/officeDocument/2006/relationships" id="262" r:id="Rbd357faf471e4dbe"/>
+    <p:sldId xmlns:r="http://schemas.openxmlformats.org/officeDocument/2006/relationships" id="263" r:id="Ra685c171f9b741ce"/>
+    <p:sldId xmlns:r="http://schemas.openxmlformats.org/officeDocument/2006/relationships" id="264" r:id="R6de2e6eab7e84948"/>
+    <p:sldId xmlns:r="http://schemas.openxmlformats.org/officeDocument/2006/relationships" id="265" r:id="Rffc8da5f8702435c"/>
+    <p:sldId xmlns:r="http://schemas.openxmlformats.org/officeDocument/2006/relationships" id="266" r:id="Rb3f5974e302e4bbc"/>
   </p:sldIdLst>
   <p:sldSz cx="12192000" cy="6858000"/>
   <p:notesSz cx="6858000" cy="9144000"/>
@@ -261,7 +262,7 @@
 </p:notesMaster>
 </file>
 
-<file path=ppt/notesMasters/theme/theme2.xml><?xml version="1.0" encoding="utf-8"?>
+<file path=ppt/notesMasters/theme/theme3.xml><?xml version="1.0" encoding="utf-8"?>
 <a:theme xmlns:a="http://schemas.openxmlformats.org/drawingml/2006/main" name="ChatGPT">
   <a:themeElements>
     <a:clrScheme name="ChatGPT">
@@ -592,6 +593,72 @@
 </p:notes>
 </file>
 
+<file path=ppt/notesSlides/notesSlide11.xml><?xml version="1.0" encoding="utf-8"?>
+<p:notes xmlns:p="http://schemas.openxmlformats.org/presentationml/2006/main">
+  <p:cSld>
+    <p:spTree>
+      <p:nvGrpSpPr>
+        <p:cNvPr id="1" name=""/>
+        <p:cNvGrpSpPr/>
+        <p:nvPr/>
+      </p:nvGrpSpPr>
+      <p:grpSpPr>
+        <a:xfrm xmlns:a="http://schemas.openxmlformats.org/drawingml/2006/main"/>
+      </p:grpSpPr>
+      <p:sp>
+        <p:nvSpPr>
+          <p:cNvPr id="2" name="Slide Image Placeholder 1"/>
+          <p:cNvSpPr>
+            <a:spLocks xmlns:a="http://schemas.openxmlformats.org/drawingml/2006/main" noGrp="1"/>
+          </p:cNvSpPr>
+          <p:nvPr>
+            <p:ph type="sldImg" idx="0"/>
+          </p:nvPr>
+        </p:nvSpPr>
+        <p:spPr/>
+      </p:sp>
+      <p:sp>
+        <p:nvSpPr>
+          <p:cNvPr id="3" name="Notes Placeholder 2"/>
+          <p:cNvSpPr>
+            <a:spLocks xmlns:a="http://schemas.openxmlformats.org/drawingml/2006/main" noGrp="1"/>
+          </p:cNvSpPr>
+          <p:nvPr>
+            <p:ph type="body" idx="1"/>
+          </p:nvPr>
+        </p:nvSpPr>
+        <p:spPr/>
+        <p:txBody>
+          <a:bodyPr xmlns:a="http://schemas.openxmlformats.org/drawingml/2006/main"/>
+          <a:lstStyle xmlns:a="http://schemas.openxmlformats.org/drawingml/2006/main"/>
+          <a:p xmlns:a="http://schemas.openxmlformats.org/drawingml/2006/main"/>
+        </p:txBody>
+      </p:sp>
+      <p:sp>
+        <p:nvSpPr>
+          <p:cNvPr id="4" name="Slide Number Placeholder 3"/>
+          <p:cNvSpPr>
+            <a:spLocks xmlns:a="http://schemas.openxmlformats.org/drawingml/2006/main" noGrp="1"/>
+          </p:cNvSpPr>
+          <p:nvPr>
+            <p:ph type="sldNum" idx="5"/>
+          </p:nvPr>
+        </p:nvSpPr>
+        <p:spPr/>
+        <p:txBody>
+          <a:bodyPr xmlns:a="http://schemas.openxmlformats.org/drawingml/2006/main"/>
+          <a:lstStyle xmlns:a="http://schemas.openxmlformats.org/drawingml/2006/main"/>
+          <a:p xmlns:a="http://schemas.openxmlformats.org/drawingml/2006/main"/>
+        </p:txBody>
+      </p:sp>
+    </p:spTree>
+  </p:cSld>
+  <p:clrMapOvr>
+    <a:masterClrMapping xmlns:a="http://schemas.openxmlformats.org/drawingml/2006/main"/>
+  </p:clrMapOvr>
+</p:notes>
+</file>
+
 <file path=ppt/notesSlides/notesSlide2.xml><?xml version="1.0" encoding="utf-8"?>
 <p:notes xmlns:p="http://schemas.openxmlformats.org/presentationml/2006/main">
   <p:cSld>
@@ -1120,7 +1187,7 @@
 </p:notes>
 </file>
 
-<file path=ppt/slideLayouts/slideLayout2.xml><?xml version="1.0" encoding="utf-8"?>
+<file path=ppt/slideLayouts/slideLayout1.xml><?xml version="1.0" encoding="utf-8"?>
 <p:sldLayout xmlns:p="http://schemas.openxmlformats.org/presentationml/2006/main" type="title">
   <p:cSld name="Title Slide">
     <p:spTree>
@@ -1158,7 +1225,7 @@
   </p:cSld>
   <p:clrMap bg1="lt1" tx1="dk1" bg2="lt2" tx2="dk2" accent1="accent1" accent2="accent2" accent3="accent3" accent4="accent4" accent5="accent5" accent6="accent6" hlink="hlink" folHlink="folHlink"/>
   <p:sldLayoutIdLst>
-    <p:sldLayoutId xmlns:r="http://schemas.openxmlformats.org/officeDocument/2006/relationships" id="2147483649" r:id="R30c8bb6011e54149"/>
+    <p:sldLayoutId xmlns:r="http://schemas.openxmlformats.org/officeDocument/2006/relationships" id="2147483649" r:id="Rb7687baf2a604a5d"/>
   </p:sldLayoutIdLst>
   <p:txStyles>
     <p:titleStyle>
@@ -1440,6 +1507,205 @@
 </p:sldMaster>
 </file>
 
+<file path=ppt/slideMasters/theme/theme2.xml><?xml version="1.0" encoding="utf-8"?>
+<a:theme xmlns:a="http://schemas.openxmlformats.org/drawingml/2006/main" name="ChatGPT">
+  <a:themeElements>
+    <a:clrScheme name="ChatGPT">
+      <a:dk1>
+        <a:srgbClr val="000000"/>
+      </a:dk1>
+      <a:lt1>
+        <a:srgbClr val="FFFFFF"/>
+      </a:lt1>
+      <a:dk2>
+        <a:srgbClr val="0E2841"/>
+      </a:dk2>
+      <a:lt2>
+        <a:srgbClr val="E8E8E8"/>
+      </a:lt2>
+      <a:accent1>
+        <a:srgbClr val="156082"/>
+      </a:accent1>
+      <a:accent2>
+        <a:srgbClr val="E97132"/>
+      </a:accent2>
+      <a:accent3>
+        <a:srgbClr val="196B24"/>
+      </a:accent3>
+      <a:accent4>
+        <a:srgbClr val="0F9ED5"/>
+      </a:accent4>
+      <a:accent5>
+        <a:srgbClr val="A02B93"/>
+      </a:accent5>
+      <a:accent6>
+        <a:srgbClr val="4EA72E"/>
+      </a:accent6>
+      <a:hlink>
+        <a:srgbClr val="467886"/>
+      </a:hlink>
+      <a:folHlink>
+        <a:srgbClr val="96607D"/>
+      </a:folHlink>
+    </a:clrScheme>
+    <a:fontScheme name="Office">
+      <a:majorFont>
+        <a:latin typeface="Calibri Light"/>
+        <a:ea typeface="Calibri Light"/>
+        <a:cs typeface="Calibri Light"/>
+      </a:majorFont>
+      <a:minorFont>
+        <a:latin typeface="Calibri"/>
+        <a:ea typeface="Calibri"/>
+        <a:cs typeface="Calibri"/>
+      </a:minorFont>
+    </a:fontScheme>
+    <a:fmtScheme name="ChatGPT">
+      <a:fillStyleLst>
+        <a:solidFill>
+          <a:schemeClr val="phClr"/>
+        </a:solidFill>
+        <a:solidFill>
+          <a:schemeClr val="dk1"/>
+        </a:solidFill>
+        <a:solidFill>
+          <a:schemeClr val="accent1"/>
+        </a:solidFill>
+      </a:fillStyleLst>
+      <a:lnStyleLst>
+        <a:ln w="12700">
+          <a:solidFill>
+            <a:schemeClr val="phClr"/>
+          </a:solidFill>
+          <a:prstDash val="solid"/>
+        </a:ln>
+        <a:ln w="19050">
+          <a:solidFill>
+            <a:schemeClr val="phClr"/>
+          </a:solidFill>
+          <a:prstDash val="solid"/>
+        </a:ln>
+        <a:ln w="25400">
+          <a:solidFill>
+            <a:schemeClr val="phClr"/>
+          </a:solidFill>
+          <a:prstDash val="solid"/>
+        </a:ln>
+      </a:lnStyleLst>
+      <a:effectStyleLst>
+        <a:effectStyle>
+          <a:effectLst/>
+        </a:effectStyle>
+        <a:effectStyle>
+          <a:effectLst/>
+        </a:effectStyle>
+        <a:effectStyle>
+          <a:effectLst>
+            <a:outerShdw blurRad="57150" dist="19050" dir="5400000">
+              <a:srgbClr val="000000">
+                <a:alpha val="16000"/>
+              </a:srgbClr>
+            </a:outerShdw>
+          </a:effectLst>
+        </a:effectStyle>
+        <a:effectStyle>
+          <a:effectLst>
+            <a:outerShdw blurRad="19050" dist="9525" dir="5400000">
+              <a:srgbClr val="000000">
+                <a:alpha val="6000"/>
+              </a:srgbClr>
+            </a:outerShdw>
+          </a:effectLst>
+        </a:effectStyle>
+        <a:effectStyle>
+          <a:effectLst>
+            <a:outerShdw blurRad="28575" dist="9525" dir="5400000">
+              <a:srgbClr val="000000">
+                <a:alpha val="8000"/>
+              </a:srgbClr>
+            </a:outerShdw>
+          </a:effectLst>
+        </a:effectStyle>
+        <a:effectStyle>
+          <a:effectLst>
+            <a:outerShdw blurRad="57150" dist="19050" dir="5400000">
+              <a:srgbClr val="000000">
+                <a:alpha val="10000"/>
+              </a:srgbClr>
+            </a:outerShdw>
+          </a:effectLst>
+        </a:effectStyle>
+        <a:effectStyle>
+          <a:effectLst>
+            <a:outerShdw blurRad="114300" dist="38100" dir="5400000">
+              <a:srgbClr val="000000">
+                <a:alpha val="12000"/>
+              </a:srgbClr>
+            </a:outerShdw>
+          </a:effectLst>
+        </a:effectStyle>
+        <a:effectStyle>
+          <a:effectLst>
+            <a:outerShdw blurRad="171450" dist="57150" dir="5400000">
+              <a:srgbClr val="000000">
+                <a:alpha val="16000"/>
+              </a:srgbClr>
+            </a:outerShdw>
+          </a:effectLst>
+        </a:effectStyle>
+        <a:effectStyle>
+          <a:effectLst>
+            <a:outerShdw blurRad="266700" dist="95250" dir="5400000">
+              <a:srgbClr val="000000">
+                <a:alpha val="24000"/>
+              </a:srgbClr>
+            </a:outerShdw>
+          </a:effectLst>
+        </a:effectStyle>
+      </a:effectStyleLst>
+      <a:bgFillStyleLst>
+        <a:solidFill>
+          <a:schemeClr val="phClr"/>
+        </a:solidFill>
+        <a:solidFill>
+          <a:schemeClr val="phClr">
+            <a:tint val="95000"/>
+            <a:satMod val="170000"/>
+          </a:schemeClr>
+        </a:solidFill>
+        <a:gradFill>
+          <a:gsLst>
+            <a:gs pos="0">
+              <a:schemeClr val="phClr">
+                <a:tint val="93000"/>
+                <a:shade val="98000"/>
+                <a:lumMod val="102000"/>
+                <a:satMod val="150000"/>
+              </a:schemeClr>
+            </a:gs>
+            <a:gs pos="50000">
+              <a:schemeClr val="phClr">
+                <a:tint val="98000"/>
+                <a:shade val="90000"/>
+                <a:lumMod val="103000"/>
+                <a:satMod val="130000"/>
+              </a:schemeClr>
+            </a:gs>
+            <a:gs pos="100000">
+              <a:schemeClr val="phClr">
+                <a:shade val="63000"/>
+                <a:satMod val="120000"/>
+              </a:schemeClr>
+            </a:gs>
+          </a:gsLst>
+          <a:lin ang="5400000" scaled="0"/>
+        </a:gradFill>
+      </a:bgFillStyleLst>
+    </a:fmtScheme>
+  </a:themeElements>
+</a:theme>
+</file>
+
 <file path=ppt/slides/slide1.xml><?xml version="1.0" encoding="utf-8"?>
 <p:sld xmlns:p="http://schemas.openxmlformats.org/presentationml/2006/main">
   <p:cSld>
@@ -1563,6 +1829,7 @@
           <a:lstStyle xmlns:a="http://schemas.openxmlformats.org/drawingml/2006/main"/>
           <a:p xmlns:a="http://schemas.openxmlformats.org/drawingml/2006/main">
             <a:pPr algn="l">
+              <a:buNone/>
               <a:defRPr sz="1125" b="1">
                 <a:solidFill>
                   <a:srgbClr val="2563EB"/>
@@ -1581,7 +1848,7 @@
                 <a:ea typeface="Aptos"/>
                 <a:cs typeface="Aptos"/>
               </a:rPr>
-              <a:t>FACULTATIVE-AEROBE INCREASED-PROFILE SIGNAL</a:t>
+              <a:t>FACULTATIVE-AEROBE V2 INCREASED-PROFILE SIGNAL</a:t>
             </a:r>
           </a:p>
         </p:txBody>
@@ -1627,6 +1894,7 @@
           <a:lstStyle xmlns:a="http://schemas.openxmlformats.org/drawingml/2006/main"/>
           <a:p xmlns:a="http://schemas.openxmlformats.org/drawingml/2006/main">
             <a:pPr algn="l">
+              <a:buNone/>
               <a:defRPr sz="2025" b="1">
                 <a:solidFill>
                   <a:srgbClr val="0F172A"/>
@@ -1685,19 +1953,19 @@
       </p:sp>
       <p:pic>
         <p:nvPicPr>
-          <p:cNvPr id="6" name=""/>
+          <p:cNvPr id="14" name="candidate_taxa_increased_profile_tendency"/>
           <p:cNvPicPr>
             <a:picLocks xmlns:a="http://schemas.openxmlformats.org/drawingml/2006/main" noChangeAspect="1"/>
           </p:cNvPicPr>
           <p:nvPr/>
         </p:nvPicPr>
         <p:blipFill>
-          <a:blip xmlns:r="http://schemas.openxmlformats.org/officeDocument/2006/relationships" xmlns:a="http://schemas.openxmlformats.org/drawingml/2006/main" r:embed="Rce42ca3099b547ab"/>
+          <a:blip xmlns:r="http://schemas.openxmlformats.org/officeDocument/2006/relationships" xmlns:a="http://schemas.openxmlformats.org/drawingml/2006/main" r:embed="Rf16c365c3eb741ef"/>
           <a:stretch xmlns:a="http://schemas.openxmlformats.org/drawingml/2006/main"/>
         </p:blipFill>
         <p:spPr>
           <a:xfrm xmlns:a="http://schemas.openxmlformats.org/drawingml/2006/main">
-            <a:off x="1647825" y="1200150"/>
+            <a:off x="1666875" y="1200150"/>
             <a:ext cx="8858250" cy="5314950"/>
           </a:xfrm>
           <a:prstGeom xmlns:a="http://schemas.openxmlformats.org/drawingml/2006/main" prst="rect">
@@ -1746,6 +2014,7 @@
           <a:lstStyle xmlns:a="http://schemas.openxmlformats.org/drawingml/2006/main"/>
           <a:p xmlns:a="http://schemas.openxmlformats.org/drawingml/2006/main">
             <a:pPr algn="r">
+              <a:buNone/>
               <a:defRPr sz="975" b="0">
                 <a:solidFill>
                   <a:srgbClr val="64748B"/>
@@ -1764,7 +2033,7 @@
                 <a:ea typeface="Aptos"/>
                 <a:cs typeface="Aptos"/>
               </a:rPr>
-              <a:t>1/10</a:t>
+              <a:t>1/11</a:t>
             </a:r>
           </a:p>
         </p:txBody>
@@ -1902,6 +2171,7 @@
           <a:lstStyle xmlns:a="http://schemas.openxmlformats.org/drawingml/2006/main"/>
           <a:p xmlns:a="http://schemas.openxmlformats.org/drawingml/2006/main">
             <a:pPr algn="l">
+              <a:buNone/>
               <a:defRPr sz="1125" b="1">
                 <a:solidFill>
                   <a:srgbClr val="0F766E"/>
@@ -1920,7 +2190,7 @@
                 <a:ea typeface="Aptos"/>
                 <a:cs typeface="Aptos"/>
               </a:rPr>
-              <a:t>GUT ANAEROBE/FERMENTATION DEPLETION</a:t>
+              <a:t>GUT ANAEROBE V2 DEPLETION</a:t>
             </a:r>
           </a:p>
         </p:txBody>
@@ -1966,6 +2236,7 @@
           <a:lstStyle xmlns:a="http://schemas.openxmlformats.org/drawingml/2006/main"/>
           <a:p xmlns:a="http://schemas.openxmlformats.org/drawingml/2006/main">
             <a:pPr algn="l">
+              <a:buNone/>
               <a:defRPr sz="2025" b="1">
                 <a:solidFill>
                   <a:srgbClr val="0F172A"/>
@@ -2024,19 +2295,19 @@
       </p:sp>
       <p:pic>
         <p:nvPicPr>
-          <p:cNvPr id="6" name=""/>
+          <p:cNvPr id="14" name="target_taxa_condition_breakdown_bar"/>
           <p:cNvPicPr>
             <a:picLocks xmlns:a="http://schemas.openxmlformats.org/drawingml/2006/main" noChangeAspect="1"/>
           </p:cNvPicPr>
           <p:nvPr/>
         </p:nvPicPr>
         <p:blipFill>
-          <a:blip xmlns:r="http://schemas.openxmlformats.org/officeDocument/2006/relationships" xmlns:a="http://schemas.openxmlformats.org/drawingml/2006/main" r:embed="R6a64c7bd39144389"/>
+          <a:blip xmlns:r="http://schemas.openxmlformats.org/officeDocument/2006/relationships" xmlns:a="http://schemas.openxmlformats.org/drawingml/2006/main" r:embed="Re1d950abae3c47b7"/>
           <a:stretch xmlns:a="http://schemas.openxmlformats.org/drawingml/2006/main"/>
         </p:blipFill>
         <p:spPr>
           <a:xfrm xmlns:a="http://schemas.openxmlformats.org/drawingml/2006/main">
-            <a:off x="2285210" y="1200150"/>
+            <a:off x="2304308" y="1200150"/>
             <a:ext cx="7583479" cy="5314950"/>
           </a:xfrm>
           <a:prstGeom xmlns:a="http://schemas.openxmlformats.org/drawingml/2006/main" prst="rect">
@@ -2085,6 +2356,7 @@
           <a:lstStyle xmlns:a="http://schemas.openxmlformats.org/drawingml/2006/main"/>
           <a:p xmlns:a="http://schemas.openxmlformats.org/drawingml/2006/main">
             <a:pPr algn="r">
+              <a:buNone/>
               <a:defRPr sz="975" b="0">
                 <a:solidFill>
                   <a:srgbClr val="64748B"/>
@@ -2103,7 +2375,7 @@
                 <a:ea typeface="Aptos"/>
                 <a:cs typeface="Aptos"/>
               </a:rPr>
-              <a:t>10/10</a:t>
+              <a:t>10/11</a:t>
             </a:r>
           </a:p>
         </p:txBody>
@@ -2112,6 +2384,298 @@
     <p:extLst>
       <p:ext uri="{BB962C8B-B14F-4D97-AF65-F5344CB8AC3E}">
         <p14:creationId xmlns:p14="http://schemas.microsoft.com/office/powerpoint/2010/main" val="1270552470"/>
+      </p:ext>
+    </p:extLst>
+  </p:cSld>
+</p:sld>
+</file>
+
+<file path=ppt/slides/slide11.xml><?xml version="1.0" encoding="utf-8"?>
+<p:sld xmlns:p="http://schemas.openxmlformats.org/presentationml/2006/main">
+  <p:cSld>
+    <p:spTree>
+      <p:nvGrpSpPr>
+        <p:cNvPr id="1" name=""/>
+        <p:cNvGrpSpPr/>
+        <p:nvPr/>
+      </p:nvGrpSpPr>
+      <p:grpSpPr>
+        <a:xfrm xmlns:a="http://schemas.openxmlformats.org/drawingml/2006/main"/>
+      </p:grpSpPr>
+      <p:sp>
+        <p:nvSpPr>
+          <p:cNvPr id="1" name="">
+            <a:extLst xmlns:a="http://schemas.openxmlformats.org/drawingml/2006/main">
+              <a:ext uri="{FF2B5EF4-FFF2-40B4-BE49-F238E27FC236}">
+                <a16:creationId xmlns:a16="http://schemas.microsoft.com/office/drawing/2014/main" id="{E945EA0B-4413-4573-8689-0505E19F8381}"/>
+              </a:ext>
+            </a:extLst>
+          </p:cNvPr>
+          <p:cNvSpPr>
+            <a:spLocks xmlns:a="http://schemas.openxmlformats.org/drawingml/2006/main" noGrp="1"/>
+          </p:cNvSpPr>
+          <p:nvPr/>
+        </p:nvSpPr>
+        <p:spPr>
+          <a:xfrm xmlns:a="http://schemas.openxmlformats.org/drawingml/2006/main">
+            <a:off x="0" y="0"/>
+            <a:ext cx="12192000" cy="6858000"/>
+          </a:xfrm>
+          <a:prstGeom xmlns:a="http://schemas.openxmlformats.org/drawingml/2006/main" prst="rect">
+            <a:avLst/>
+          </a:prstGeom>
+          <a:solidFill xmlns:a="http://schemas.openxmlformats.org/drawingml/2006/main">
+            <a:srgbClr val="F8FAFC"/>
+          </a:solidFill>
+          <a:ln xmlns:a="http://schemas.openxmlformats.org/drawingml/2006/main" w="0">
+            <a:noFill/>
+            <a:prstDash val="solid"/>
+          </a:ln>
+        </p:spPr>
+      </p:sp>
+      <p:sp>
+        <p:nvSpPr>
+          <p:cNvPr id="2" name="">
+            <a:extLst xmlns:a="http://schemas.openxmlformats.org/drawingml/2006/main">
+              <a:ext uri="{FF2B5EF4-FFF2-40B4-BE49-F238E27FC236}">
+                <a16:creationId xmlns:a16="http://schemas.microsoft.com/office/drawing/2014/main" id="{5D929A38-2E11-4FB0-8142-AA223E9F36A1}"/>
+              </a:ext>
+            </a:extLst>
+          </p:cNvPr>
+          <p:cNvSpPr>
+            <a:spLocks xmlns:a="http://schemas.openxmlformats.org/drawingml/2006/main" noGrp="1"/>
+          </p:cNvSpPr>
+          <p:nvPr/>
+        </p:nvSpPr>
+        <p:spPr>
+          <a:xfrm xmlns:a="http://schemas.openxmlformats.org/drawingml/2006/main">
+            <a:off x="0" y="0"/>
+            <a:ext cx="12192000" cy="57150"/>
+          </a:xfrm>
+          <a:prstGeom xmlns:a="http://schemas.openxmlformats.org/drawingml/2006/main" prst="rect">
+            <a:avLst/>
+          </a:prstGeom>
+          <a:solidFill xmlns:a="http://schemas.openxmlformats.org/drawingml/2006/main">
+            <a:srgbClr val="4F46E5"/>
+          </a:solidFill>
+          <a:ln xmlns:a="http://schemas.openxmlformats.org/drawingml/2006/main" w="0">
+            <a:noFill/>
+            <a:prstDash val="solid"/>
+          </a:ln>
+        </p:spPr>
+      </p:sp>
+      <p:sp>
+        <p:nvSpPr>
+          <p:cNvPr id="3" name="">
+            <a:extLst xmlns:a="http://schemas.openxmlformats.org/drawingml/2006/main">
+              <a:ext uri="{FF2B5EF4-FFF2-40B4-BE49-F238E27FC236}">
+                <a16:creationId xmlns:a16="http://schemas.microsoft.com/office/drawing/2014/main" id="{7C1DCD72-D491-4269-80E2-0BAE3C5D9235}"/>
+              </a:ext>
+            </a:extLst>
+          </p:cNvPr>
+          <p:cNvSpPr>
+            <a:spLocks xmlns:a="http://schemas.openxmlformats.org/drawingml/2006/main" noGrp="1"/>
+          </p:cNvSpPr>
+          <p:nvPr/>
+        </p:nvSpPr>
+        <p:spPr>
+          <a:xfrm xmlns:a="http://schemas.openxmlformats.org/drawingml/2006/main">
+            <a:off x="533400" y="285750"/>
+            <a:ext cx="8096250" cy="228600"/>
+          </a:xfrm>
+          <a:prstGeom xmlns:a="http://schemas.openxmlformats.org/drawingml/2006/main" prst="rect">
+            <a:avLst/>
+          </a:prstGeom>
+          <a:noFill xmlns:a="http://schemas.openxmlformats.org/drawingml/2006/main"/>
+          <a:ln xmlns:a="http://schemas.openxmlformats.org/drawingml/2006/main" w="0">
+            <a:noFill/>
+            <a:prstDash val="solid"/>
+          </a:ln>
+        </p:spPr>
+        <p:txBody>
+          <a:bodyPr xmlns:a="http://schemas.openxmlformats.org/drawingml/2006/main"/>
+          <a:lstStyle xmlns:a="http://schemas.openxmlformats.org/drawingml/2006/main"/>
+          <a:p xmlns:a="http://schemas.openxmlformats.org/drawingml/2006/main">
+            <a:pPr>
+              <a:buNone/>
+              <a:defRPr sz="975" b="1">
+                <a:solidFill>
+                  <a:srgbClr val="475569"/>
+                </a:solidFill>
+              </a:defRPr>
+            </a:pPr>
+            <a:r>
+              <a:rPr sz="975" b="1">
+                <a:solidFill>
+                  <a:srgbClr val="475569"/>
+                </a:solidFill>
+              </a:rPr>
+              <a:t>PROFILE ENRICHMENT TO GUILD ASSIGNMENT</a:t>
+            </a:r>
+          </a:p>
+        </p:txBody>
+      </p:sp>
+      <p:sp>
+        <p:nvSpPr>
+          <p:cNvPr id="4" name="">
+            <a:extLst xmlns:a="http://schemas.openxmlformats.org/drawingml/2006/main">
+              <a:ext uri="{FF2B5EF4-FFF2-40B4-BE49-F238E27FC236}">
+                <a16:creationId xmlns:a16="http://schemas.microsoft.com/office/drawing/2014/main" id="{4A2205C7-6C5C-4722-BB61-919AF080E232}"/>
+              </a:ext>
+            </a:extLst>
+          </p:cNvPr>
+          <p:cNvSpPr>
+            <a:spLocks xmlns:a="http://schemas.openxmlformats.org/drawingml/2006/main" noGrp="1"/>
+          </p:cNvSpPr>
+          <p:nvPr/>
+        </p:nvSpPr>
+        <p:spPr>
+          <a:xfrm xmlns:a="http://schemas.openxmlformats.org/drawingml/2006/main">
+            <a:off x="533400" y="552450"/>
+            <a:ext cx="10096500" cy="419100"/>
+          </a:xfrm>
+          <a:prstGeom xmlns:a="http://schemas.openxmlformats.org/drawingml/2006/main" prst="rect">
+            <a:avLst/>
+          </a:prstGeom>
+          <a:noFill xmlns:a="http://schemas.openxmlformats.org/drawingml/2006/main"/>
+          <a:ln xmlns:a="http://schemas.openxmlformats.org/drawingml/2006/main" w="0">
+            <a:noFill/>
+            <a:prstDash val="solid"/>
+          </a:ln>
+        </p:spPr>
+        <p:txBody>
+          <a:bodyPr xmlns:a="http://schemas.openxmlformats.org/drawingml/2006/main"/>
+          <a:lstStyle xmlns:a="http://schemas.openxmlformats.org/drawingml/2006/main"/>
+          <a:p xmlns:a="http://schemas.openxmlformats.org/drawingml/2006/main">
+            <a:pPr>
+              <a:buNone/>
+              <a:defRPr sz="2100" b="1">
+                <a:solidFill>
+                  <a:srgbClr val="0F172A"/>
+                </a:solidFill>
+              </a:defRPr>
+            </a:pPr>
+            <a:r>
+              <a:rPr sz="2100" b="1">
+                <a:solidFill>
+                  <a:srgbClr val="0F172A"/>
+                </a:solidFill>
+              </a:rPr>
+              <a:t/>
+            </a:r>
+          </a:p>
+        </p:txBody>
+      </p:sp>
+      <p:sp>
+        <p:nvSpPr>
+          <p:cNvPr id="5" name="">
+            <a:extLst xmlns:a="http://schemas.openxmlformats.org/drawingml/2006/main">
+              <a:ext uri="{FF2B5EF4-FFF2-40B4-BE49-F238E27FC236}">
+                <a16:creationId xmlns:a16="http://schemas.microsoft.com/office/drawing/2014/main" id="{75102D3F-BF31-48DB-9E91-66D9F92C9174}"/>
+              </a:ext>
+            </a:extLst>
+          </p:cNvPr>
+          <p:cNvSpPr>
+            <a:spLocks xmlns:a="http://schemas.openxmlformats.org/drawingml/2006/main" noGrp="1"/>
+          </p:cNvSpPr>
+          <p:nvPr/>
+        </p:nvSpPr>
+        <p:spPr>
+          <a:xfrm xmlns:a="http://schemas.openxmlformats.org/drawingml/2006/main">
+            <a:off x="11144250" y="314325"/>
+            <a:ext cx="609600" cy="190500"/>
+          </a:xfrm>
+          <a:prstGeom xmlns:a="http://schemas.openxmlformats.org/drawingml/2006/main" prst="rect">
+            <a:avLst/>
+          </a:prstGeom>
+          <a:noFill xmlns:a="http://schemas.openxmlformats.org/drawingml/2006/main"/>
+          <a:ln xmlns:a="http://schemas.openxmlformats.org/drawingml/2006/main" w="0">
+            <a:noFill/>
+            <a:prstDash val="solid"/>
+          </a:ln>
+        </p:spPr>
+        <p:txBody>
+          <a:bodyPr xmlns:a="http://schemas.openxmlformats.org/drawingml/2006/main"/>
+          <a:lstStyle xmlns:a="http://schemas.openxmlformats.org/drawingml/2006/main"/>
+          <a:p xmlns:a="http://schemas.openxmlformats.org/drawingml/2006/main">
+            <a:pPr>
+              <a:buNone/>
+              <a:defRPr sz="900">
+                <a:solidFill>
+                  <a:srgbClr val="64748B"/>
+                </a:solidFill>
+              </a:defRPr>
+            </a:pPr>
+            <a:r>
+              <a:rPr sz="900">
+                <a:solidFill>
+                  <a:srgbClr val="64748B"/>
+                </a:solidFill>
+              </a:rPr>
+              <a:t>11/11</a:t>
+            </a:r>
+          </a:p>
+        </p:txBody>
+      </p:sp>
+      <p:sp>
+        <p:nvSpPr>
+          <p:cNvPr id="6" name="">
+            <a:extLst xmlns:a="http://schemas.openxmlformats.org/drawingml/2006/main">
+              <a:ext uri="{FF2B5EF4-FFF2-40B4-BE49-F238E27FC236}">
+                <a16:creationId xmlns:a16="http://schemas.microsoft.com/office/drawing/2014/main" id="{7F2F241F-E84E-4645-9562-EB131ADD844D}"/>
+              </a:ext>
+            </a:extLst>
+          </p:cNvPr>
+          <p:cNvSpPr>
+            <a:spLocks xmlns:a="http://schemas.openxmlformats.org/drawingml/2006/main" noGrp="1"/>
+          </p:cNvSpPr>
+          <p:nvPr/>
+        </p:nvSpPr>
+        <p:spPr>
+          <a:xfrm xmlns:a="http://schemas.openxmlformats.org/drawingml/2006/main">
+            <a:off x="304800" y="742950"/>
+            <a:ext cx="11582400" cy="5867400"/>
+          </a:xfrm>
+          <a:prstGeom xmlns:a="http://schemas.openxmlformats.org/drawingml/2006/main" prst="rect">
+            <a:avLst/>
+          </a:prstGeom>
+          <a:solidFill xmlns:a="http://schemas.openxmlformats.org/drawingml/2006/main">
+            <a:srgbClr val="FFFFFF"/>
+          </a:solidFill>
+          <a:ln xmlns:a="http://schemas.openxmlformats.org/drawingml/2006/main" w="9525">
+            <a:solidFill>
+              <a:srgbClr val="CBD5E1"/>
+            </a:solidFill>
+            <a:prstDash val="solid"/>
+          </a:ln>
+        </p:spPr>
+      </p:sp>
+      <p:pic>
+        <p:nvPicPr>
+          <p:cNvPr id="14" name=""/>
+          <p:cNvPicPr>
+            <a:picLocks xmlns:a="http://schemas.openxmlformats.org/drawingml/2006/main" noChangeAspect="1"/>
+          </p:cNvPicPr>
+          <p:nvPr/>
+        </p:nvPicPr>
+        <p:blipFill>
+          <a:blip xmlns:r="http://schemas.openxmlformats.org/officeDocument/2006/relationships" xmlns:a="http://schemas.openxmlformats.org/drawingml/2006/main" r:embed="R16fa5d5ec13646d5"/>
+          <a:stretch xmlns:a="http://schemas.openxmlformats.org/drawingml/2006/main"/>
+        </p:blipFill>
+        <p:spPr>
+          <a:xfrm xmlns:a="http://schemas.openxmlformats.org/drawingml/2006/main">
+            <a:off x="381000" y="819150"/>
+            <a:ext cx="11430000" cy="5715000"/>
+          </a:xfrm>
+          <a:prstGeom xmlns:a="http://schemas.openxmlformats.org/drawingml/2006/main" prst="rect">
+            <a:avLst/>
+          </a:prstGeom>
+        </p:spPr>
+      </p:pic>
+    </p:spTree>
+    <p:extLst>
+      <p:ext uri="{BB962C8B-B14F-4D97-AF65-F5344CB8AC3E}">
+        <p14:creationId xmlns:p14="http://schemas.microsoft.com/office/powerpoint/2010/main" val="1263696544"/>
       </p:ext>
     </p:extLst>
   </p:cSld>
@@ -2241,6 +2805,7 @@
           <a:lstStyle xmlns:a="http://schemas.openxmlformats.org/drawingml/2006/main"/>
           <a:p xmlns:a="http://schemas.openxmlformats.org/drawingml/2006/main">
             <a:pPr algn="l">
+              <a:buNone/>
               <a:defRPr sz="1125" b="1">
                 <a:solidFill>
                   <a:srgbClr val="2563EB"/>
@@ -2259,7 +2824,7 @@
                 <a:ea typeface="Aptos"/>
                 <a:cs typeface="Aptos"/>
               </a:rPr>
-              <a:t>FACULTATIVE-AEROBE INCREASED-PROFILE SIGNAL</a:t>
+              <a:t>FACULTATIVE-AEROBE V2 INCREASED-PROFILE SIGNAL</a:t>
             </a:r>
           </a:p>
         </p:txBody>
@@ -2305,6 +2870,7 @@
           <a:lstStyle xmlns:a="http://schemas.openxmlformats.org/drawingml/2006/main"/>
           <a:p xmlns:a="http://schemas.openxmlformats.org/drawingml/2006/main">
             <a:pPr algn="l">
+              <a:buNone/>
               <a:defRPr sz="2025" b="1">
                 <a:solidFill>
                   <a:srgbClr val="0F172A"/>
@@ -2323,7 +2889,7 @@
                 <a:ea typeface="Aptos Display"/>
                 <a:cs typeface="Aptos Display"/>
               </a:rPr>
-              <a:t>Conditions with high increased-profile guild signal</a:t>
+              <a:t>Conditions with high increased-profile v2 guild signal</a:t>
             </a:r>
           </a:p>
         </p:txBody>
@@ -2363,20 +2929,20 @@
       </p:sp>
       <p:pic>
         <p:nvPicPr>
-          <p:cNvPr id="6" name=""/>
+          <p:cNvPr id="14" name="condition_increased_guild_signal"/>
           <p:cNvPicPr>
             <a:picLocks xmlns:a="http://schemas.openxmlformats.org/drawingml/2006/main" noChangeAspect="1"/>
           </p:cNvPicPr>
           <p:nvPr/>
         </p:nvPicPr>
         <p:blipFill>
-          <a:blip xmlns:r="http://schemas.openxmlformats.org/officeDocument/2006/relationships" xmlns:a="http://schemas.openxmlformats.org/drawingml/2006/main" r:embed="Rdaadebeb509345c9"/>
+          <a:blip xmlns:r="http://schemas.openxmlformats.org/officeDocument/2006/relationships" xmlns:a="http://schemas.openxmlformats.org/drawingml/2006/main" r:embed="Rb86cd14e596e45f7"/>
           <a:stretch xmlns:a="http://schemas.openxmlformats.org/drawingml/2006/main"/>
         </p:blipFill>
         <p:spPr>
           <a:xfrm xmlns:a="http://schemas.openxmlformats.org/drawingml/2006/main">
-            <a:off x="1245177" y="1200150"/>
-            <a:ext cx="9663545" cy="5314950"/>
+            <a:off x="781050" y="1200150"/>
+            <a:ext cx="10629900" cy="5314950"/>
           </a:xfrm>
           <a:prstGeom xmlns:a="http://schemas.openxmlformats.org/drawingml/2006/main" prst="rect">
             <a:avLst/>
@@ -2424,6 +2990,7 @@
           <a:lstStyle xmlns:a="http://schemas.openxmlformats.org/drawingml/2006/main"/>
           <a:p xmlns:a="http://schemas.openxmlformats.org/drawingml/2006/main">
             <a:pPr algn="r">
+              <a:buNone/>
               <a:defRPr sz="975" b="0">
                 <a:solidFill>
                   <a:srgbClr val="64748B"/>
@@ -2442,7 +3009,7 @@
                 <a:ea typeface="Aptos"/>
                 <a:cs typeface="Aptos"/>
               </a:rPr>
-              <a:t>2/10</a:t>
+              <a:t>2/11</a:t>
             </a:r>
           </a:p>
         </p:txBody>
@@ -2580,6 +3147,7 @@
           <a:lstStyle xmlns:a="http://schemas.openxmlformats.org/drawingml/2006/main"/>
           <a:p xmlns:a="http://schemas.openxmlformats.org/drawingml/2006/main">
             <a:pPr algn="l">
+              <a:buNone/>
               <a:defRPr sz="1125" b="1">
                 <a:solidFill>
                   <a:srgbClr val="2563EB"/>
@@ -2598,7 +3166,7 @@
                 <a:ea typeface="Aptos"/>
                 <a:cs typeface="Aptos"/>
               </a:rPr>
-              <a:t>FACULTATIVE-AEROBE INCREASED-PROFILE SIGNAL</a:t>
+              <a:t>FACULTATIVE-AEROBE V2 INCREASED-PROFILE SIGNAL</a:t>
             </a:r>
           </a:p>
         </p:txBody>
@@ -2644,6 +3212,7 @@
           <a:lstStyle xmlns:a="http://schemas.openxmlformats.org/drawingml/2006/main"/>
           <a:p xmlns:a="http://schemas.openxmlformats.org/drawingml/2006/main">
             <a:pPr algn="l">
+              <a:buNone/>
               <a:defRPr sz="2025" b="1">
                 <a:solidFill>
                   <a:srgbClr val="0F172A"/>
@@ -2662,7 +3231,7 @@
                 <a:ea typeface="Aptos Display"/>
                 <a:cs typeface="Aptos Display"/>
               </a:rPr>
-              <a:t>Guild traits are higher in increased profiles</a:t>
+              <a:t>V2 guild traits are higher in increased profiles</a:t>
             </a:r>
           </a:p>
         </p:txBody>
@@ -2702,19 +3271,19 @@
       </p:sp>
       <p:pic>
         <p:nvPicPr>
-          <p:cNvPr id="6" name=""/>
+          <p:cNvPr id="14" name="guild_trait_direction_shift"/>
           <p:cNvPicPr>
             <a:picLocks xmlns:a="http://schemas.openxmlformats.org/drawingml/2006/main" noChangeAspect="1"/>
           </p:cNvPicPr>
           <p:nvPr/>
         </p:nvPicPr>
         <p:blipFill>
-          <a:blip xmlns:r="http://schemas.openxmlformats.org/officeDocument/2006/relationships" xmlns:a="http://schemas.openxmlformats.org/drawingml/2006/main" r:embed="R0c461df959b6455d"/>
+          <a:blip xmlns:r="http://schemas.openxmlformats.org/officeDocument/2006/relationships" xmlns:a="http://schemas.openxmlformats.org/drawingml/2006/main" r:embed="Rf3db00a0e7d34006"/>
           <a:stretch xmlns:a="http://schemas.openxmlformats.org/drawingml/2006/main"/>
         </p:blipFill>
         <p:spPr>
           <a:xfrm xmlns:a="http://schemas.openxmlformats.org/drawingml/2006/main">
-            <a:off x="1245177" y="1200150"/>
+            <a:off x="1264275" y="1200150"/>
             <a:ext cx="9663545" cy="5314950"/>
           </a:xfrm>
           <a:prstGeom xmlns:a="http://schemas.openxmlformats.org/drawingml/2006/main" prst="rect">
@@ -2763,6 +3332,7 @@
           <a:lstStyle xmlns:a="http://schemas.openxmlformats.org/drawingml/2006/main"/>
           <a:p xmlns:a="http://schemas.openxmlformats.org/drawingml/2006/main">
             <a:pPr algn="r">
+              <a:buNone/>
               <a:defRPr sz="975" b="0">
                 <a:solidFill>
                   <a:srgbClr val="64748B"/>
@@ -2781,7 +3351,7 @@
                 <a:ea typeface="Aptos"/>
                 <a:cs typeface="Aptos"/>
               </a:rPr>
-              <a:t>3/10</a:t>
+              <a:t>3/11</a:t>
             </a:r>
           </a:p>
         </p:txBody>
@@ -2919,6 +3489,7 @@
           <a:lstStyle xmlns:a="http://schemas.openxmlformats.org/drawingml/2006/main"/>
           <a:p xmlns:a="http://schemas.openxmlformats.org/drawingml/2006/main">
             <a:pPr algn="l">
+              <a:buNone/>
               <a:defRPr sz="1125" b="1">
                 <a:solidFill>
                   <a:srgbClr val="2563EB"/>
@@ -2937,7 +3508,7 @@
                 <a:ea typeface="Aptos"/>
                 <a:cs typeface="Aptos"/>
               </a:rPr>
-              <a:t>FACULTATIVE-AEROBE INCREASED-PROFILE SIGNAL</a:t>
+              <a:t>FACULTATIVE-AEROBE V2 INCREASED-PROFILE SIGNAL</a:t>
             </a:r>
           </a:p>
         </p:txBody>
@@ -2983,6 +3554,7 @@
           <a:lstStyle xmlns:a="http://schemas.openxmlformats.org/drawingml/2006/main"/>
           <a:p xmlns:a="http://schemas.openxmlformats.org/drawingml/2006/main">
             <a:pPr algn="l">
+              <a:buNone/>
               <a:defRPr sz="2025" b="1">
                 <a:solidFill>
                   <a:srgbClr val="0F172A"/>
@@ -3001,7 +3573,7 @@
                 <a:ea typeface="Aptos Display"/>
                 <a:cs typeface="Aptos Display"/>
               </a:rPr>
-              <a:t>Anatomical sites for increased-profile facultative-aerobe signal</a:t>
+              <a:t>Anatomical sites for increased-profile facultative-aerobe v2 signal</a:t>
             </a:r>
           </a:p>
         </p:txBody>
@@ -3041,19 +3613,19 @@
       </p:sp>
       <p:pic>
         <p:nvPicPr>
-          <p:cNvPr id="6" name=""/>
+          <p:cNvPr id="14" name="anatomical_sites_diagram"/>
           <p:cNvPicPr>
             <a:picLocks xmlns:a="http://schemas.openxmlformats.org/drawingml/2006/main" noChangeAspect="1"/>
           </p:cNvPicPr>
           <p:nvPr/>
         </p:nvPicPr>
         <p:blipFill>
-          <a:blip xmlns:r="http://schemas.openxmlformats.org/officeDocument/2006/relationships" xmlns:a="http://schemas.openxmlformats.org/drawingml/2006/main" r:embed="R8b3d4edf7b054102"/>
+          <a:blip xmlns:r="http://schemas.openxmlformats.org/officeDocument/2006/relationships" xmlns:a="http://schemas.openxmlformats.org/drawingml/2006/main" r:embed="R078adfba46cf408a"/>
           <a:stretch xmlns:a="http://schemas.openxmlformats.org/drawingml/2006/main"/>
         </p:blipFill>
         <p:spPr>
           <a:xfrm xmlns:a="http://schemas.openxmlformats.org/drawingml/2006/main">
-            <a:off x="1118201" y="1200150"/>
+            <a:off x="1137299" y="1200150"/>
             <a:ext cx="9917498" cy="5314950"/>
           </a:xfrm>
           <a:prstGeom xmlns:a="http://schemas.openxmlformats.org/drawingml/2006/main" prst="rect">
@@ -3102,6 +3674,7 @@
           <a:lstStyle xmlns:a="http://schemas.openxmlformats.org/drawingml/2006/main"/>
           <a:p xmlns:a="http://schemas.openxmlformats.org/drawingml/2006/main">
             <a:pPr algn="r">
+              <a:buNone/>
               <a:defRPr sz="975" b="0">
                 <a:solidFill>
                   <a:srgbClr val="64748B"/>
@@ -3120,7 +3693,7 @@
                 <a:ea typeface="Aptos"/>
                 <a:cs typeface="Aptos"/>
               </a:rPr>
-              <a:t>4/10</a:t>
+              <a:t>4/11</a:t>
             </a:r>
           </a:p>
         </p:txBody>
@@ -3258,6 +3831,7 @@
           <a:lstStyle xmlns:a="http://schemas.openxmlformats.org/drawingml/2006/main"/>
           <a:p xmlns:a="http://schemas.openxmlformats.org/drawingml/2006/main">
             <a:pPr algn="l">
+              <a:buNone/>
               <a:defRPr sz="1125" b="1">
                 <a:solidFill>
                   <a:srgbClr val="2563EB"/>
@@ -3276,7 +3850,7 @@
                 <a:ea typeface="Aptos"/>
                 <a:cs typeface="Aptos"/>
               </a:rPr>
-              <a:t>FACULTATIVE-AEROBE INCREASED-PROFILE SIGNAL</a:t>
+              <a:t>FACULTATIVE-AEROBE V2 INCREASED-PROFILE SIGNAL</a:t>
             </a:r>
           </a:p>
         </p:txBody>
@@ -3322,6 +3896,7 @@
           <a:lstStyle xmlns:a="http://schemas.openxmlformats.org/drawingml/2006/main"/>
           <a:p xmlns:a="http://schemas.openxmlformats.org/drawingml/2006/main">
             <a:pPr algn="l">
+              <a:buNone/>
               <a:defRPr sz="2025" b="1">
                 <a:solidFill>
                   <a:srgbClr val="0F172A"/>
@@ -3380,20 +3955,20 @@
       </p:sp>
       <p:pic>
         <p:nvPicPr>
-          <p:cNvPr id="6" name=""/>
+          <p:cNvPr id="14" name="target_taxa_condition_breakdown_bar"/>
           <p:cNvPicPr>
             <a:picLocks xmlns:a="http://schemas.openxmlformats.org/drawingml/2006/main" noChangeAspect="1"/>
           </p:cNvPicPr>
           <p:nvPr/>
         </p:nvPicPr>
         <p:blipFill>
-          <a:blip xmlns:r="http://schemas.openxmlformats.org/officeDocument/2006/relationships" xmlns:a="http://schemas.openxmlformats.org/drawingml/2006/main" r:embed="R5434026b74834394"/>
+          <a:blip xmlns:r="http://schemas.openxmlformats.org/officeDocument/2006/relationships" xmlns:a="http://schemas.openxmlformats.org/drawingml/2006/main" r:embed="R5e18407430e44cd9"/>
           <a:stretch xmlns:a="http://schemas.openxmlformats.org/drawingml/2006/main"/>
         </p:blipFill>
         <p:spPr>
           <a:xfrm xmlns:a="http://schemas.openxmlformats.org/drawingml/2006/main">
-            <a:off x="2287126" y="1200150"/>
-            <a:ext cx="7579648" cy="5314950"/>
+            <a:off x="2306193" y="1200162"/>
+            <a:ext cx="7579614" cy="5314927"/>
           </a:xfrm>
           <a:prstGeom xmlns:a="http://schemas.openxmlformats.org/drawingml/2006/main" prst="rect">
             <a:avLst/>
@@ -3441,6 +4016,7 @@
           <a:lstStyle xmlns:a="http://schemas.openxmlformats.org/drawingml/2006/main"/>
           <a:p xmlns:a="http://schemas.openxmlformats.org/drawingml/2006/main">
             <a:pPr algn="r">
+              <a:buNone/>
               <a:defRPr sz="975" b="0">
                 <a:solidFill>
                   <a:srgbClr val="64748B"/>
@@ -3459,7 +4035,7 @@
                 <a:ea typeface="Aptos"/>
                 <a:cs typeface="Aptos"/>
               </a:rPr>
-              <a:t>5/10</a:t>
+              <a:t>5/11</a:t>
             </a:r>
           </a:p>
         </p:txBody>
@@ -3597,6 +4173,7 @@
           <a:lstStyle xmlns:a="http://schemas.openxmlformats.org/drawingml/2006/main"/>
           <a:p xmlns:a="http://schemas.openxmlformats.org/drawingml/2006/main">
             <a:pPr algn="l">
+              <a:buNone/>
               <a:defRPr sz="1125" b="1">
                 <a:solidFill>
                   <a:srgbClr val="0F766E"/>
@@ -3615,7 +4192,7 @@
                 <a:ea typeface="Aptos"/>
                 <a:cs typeface="Aptos"/>
               </a:rPr>
-              <a:t>GUT ANAEROBE/FERMENTATION DEPLETION</a:t>
+              <a:t>GUT ANAEROBE V2 DEPLETION</a:t>
             </a:r>
           </a:p>
         </p:txBody>
@@ -3661,6 +4238,7 @@
           <a:lstStyle xmlns:a="http://schemas.openxmlformats.org/drawingml/2006/main"/>
           <a:p xmlns:a="http://schemas.openxmlformats.org/drawingml/2006/main">
             <a:pPr algn="l">
+              <a:buNone/>
               <a:defRPr sz="2025" b="1">
                 <a:solidFill>
                   <a:srgbClr val="0F172A"/>
@@ -3719,19 +4297,19 @@
       </p:sp>
       <p:pic>
         <p:nvPicPr>
-          <p:cNvPr id="6" name=""/>
+          <p:cNvPr id="14" name="candidate_taxa_depletion_bias"/>
           <p:cNvPicPr>
             <a:picLocks xmlns:a="http://schemas.openxmlformats.org/drawingml/2006/main" noChangeAspect="1"/>
           </p:cNvPicPr>
           <p:nvPr/>
         </p:nvPicPr>
         <p:blipFill>
-          <a:blip xmlns:r="http://schemas.openxmlformats.org/officeDocument/2006/relationships" xmlns:a="http://schemas.openxmlformats.org/drawingml/2006/main" r:embed="Rf619e6391d404400"/>
+          <a:blip xmlns:r="http://schemas.openxmlformats.org/officeDocument/2006/relationships" xmlns:a="http://schemas.openxmlformats.org/drawingml/2006/main" r:embed="Raddd61b6de084da8"/>
           <a:stretch xmlns:a="http://schemas.openxmlformats.org/drawingml/2006/main"/>
         </p:blipFill>
         <p:spPr>
           <a:xfrm xmlns:a="http://schemas.openxmlformats.org/drawingml/2006/main">
-            <a:off x="1094184" y="1200150"/>
+            <a:off x="1113282" y="1200150"/>
             <a:ext cx="9965531" cy="5314950"/>
           </a:xfrm>
           <a:prstGeom xmlns:a="http://schemas.openxmlformats.org/drawingml/2006/main" prst="rect">
@@ -3780,6 +4358,7 @@
           <a:lstStyle xmlns:a="http://schemas.openxmlformats.org/drawingml/2006/main"/>
           <a:p xmlns:a="http://schemas.openxmlformats.org/drawingml/2006/main">
             <a:pPr algn="r">
+              <a:buNone/>
               <a:defRPr sz="975" b="0">
                 <a:solidFill>
                   <a:srgbClr val="64748B"/>
@@ -3798,7 +4377,7 @@
                 <a:ea typeface="Aptos"/>
                 <a:cs typeface="Aptos"/>
               </a:rPr>
-              <a:t>6/10</a:t>
+              <a:t>6/11</a:t>
             </a:r>
           </a:p>
         </p:txBody>
@@ -3936,6 +4515,7 @@
           <a:lstStyle xmlns:a="http://schemas.openxmlformats.org/drawingml/2006/main"/>
           <a:p xmlns:a="http://schemas.openxmlformats.org/drawingml/2006/main">
             <a:pPr algn="l">
+              <a:buNone/>
               <a:defRPr sz="1125" b="1">
                 <a:solidFill>
                   <a:srgbClr val="0F766E"/>
@@ -3954,7 +4534,7 @@
                 <a:ea typeface="Aptos"/>
                 <a:cs typeface="Aptos"/>
               </a:rPr>
-              <a:t>GUT ANAEROBE/FERMENTATION DEPLETION</a:t>
+              <a:t>GUT ANAEROBE V2 DEPLETION</a:t>
             </a:r>
           </a:p>
         </p:txBody>
@@ -4000,6 +4580,7 @@
           <a:lstStyle xmlns:a="http://schemas.openxmlformats.org/drawingml/2006/main"/>
           <a:p xmlns:a="http://schemas.openxmlformats.org/drawingml/2006/main">
             <a:pPr algn="l">
+              <a:buNone/>
               <a:defRPr sz="2025" b="1">
                 <a:solidFill>
                   <a:srgbClr val="0F172A"/>
@@ -4018,7 +4599,7 @@
                 <a:ea typeface="Aptos Display"/>
                 <a:cs typeface="Aptos Display"/>
               </a:rPr>
-              <a:t>Conditions with high decreased-profile guild signal</a:t>
+              <a:t>Conditions with high decreased-profile gut anaerobe v2 guild signal</a:t>
             </a:r>
           </a:p>
         </p:txBody>
@@ -4058,20 +4639,20 @@
       </p:sp>
       <p:pic>
         <p:nvPicPr>
-          <p:cNvPr id="6" name=""/>
+          <p:cNvPr id="14" name="condition_decreased_guild_signal"/>
           <p:cNvPicPr>
             <a:picLocks xmlns:a="http://schemas.openxmlformats.org/drawingml/2006/main" noChangeAspect="1"/>
           </p:cNvPicPr>
           <p:nvPr/>
         </p:nvPicPr>
         <p:blipFill>
-          <a:blip xmlns:r="http://schemas.openxmlformats.org/officeDocument/2006/relationships" xmlns:a="http://schemas.openxmlformats.org/drawingml/2006/main" r:embed="R0f3357b6e76f4fce"/>
+          <a:blip xmlns:r="http://schemas.openxmlformats.org/officeDocument/2006/relationships" xmlns:a="http://schemas.openxmlformats.org/drawingml/2006/main" r:embed="R15695ae655714ca2"/>
           <a:stretch xmlns:a="http://schemas.openxmlformats.org/drawingml/2006/main"/>
         </p:blipFill>
         <p:spPr>
           <a:xfrm xmlns:a="http://schemas.openxmlformats.org/drawingml/2006/main">
-            <a:off x="1245177" y="1200150"/>
-            <a:ext cx="9663545" cy="5314950"/>
+            <a:off x="781050" y="1200150"/>
+            <a:ext cx="10629900" cy="5314950"/>
           </a:xfrm>
           <a:prstGeom xmlns:a="http://schemas.openxmlformats.org/drawingml/2006/main" prst="rect">
             <a:avLst/>
@@ -4119,6 +4700,7 @@
           <a:lstStyle xmlns:a="http://schemas.openxmlformats.org/drawingml/2006/main"/>
           <a:p xmlns:a="http://schemas.openxmlformats.org/drawingml/2006/main">
             <a:pPr algn="r">
+              <a:buNone/>
               <a:defRPr sz="975" b="0">
                 <a:solidFill>
                   <a:srgbClr val="64748B"/>
@@ -4137,7 +4719,7 @@
                 <a:ea typeface="Aptos"/>
                 <a:cs typeface="Aptos"/>
               </a:rPr>
-              <a:t>7/10</a:t>
+              <a:t>7/11</a:t>
             </a:r>
           </a:p>
         </p:txBody>
@@ -4275,6 +4857,7 @@
           <a:lstStyle xmlns:a="http://schemas.openxmlformats.org/drawingml/2006/main"/>
           <a:p xmlns:a="http://schemas.openxmlformats.org/drawingml/2006/main">
             <a:pPr algn="l">
+              <a:buNone/>
               <a:defRPr sz="1125" b="1">
                 <a:solidFill>
                   <a:srgbClr val="0F766E"/>
@@ -4293,7 +4876,7 @@
                 <a:ea typeface="Aptos"/>
                 <a:cs typeface="Aptos"/>
               </a:rPr>
-              <a:t>GUT ANAEROBE/FERMENTATION DEPLETION</a:t>
+              <a:t>GUT ANAEROBE V2 DEPLETION</a:t>
             </a:r>
           </a:p>
         </p:txBody>
@@ -4339,6 +4922,7 @@
           <a:lstStyle xmlns:a="http://schemas.openxmlformats.org/drawingml/2006/main"/>
           <a:p xmlns:a="http://schemas.openxmlformats.org/drawingml/2006/main">
             <a:pPr algn="l">
+              <a:buNone/>
               <a:defRPr sz="2025" b="1">
                 <a:solidFill>
                   <a:srgbClr val="0F172A"/>
@@ -4357,7 +4941,7 @@
                 <a:ea typeface="Aptos Display"/>
                 <a:cs typeface="Aptos Display"/>
               </a:rPr>
-              <a:t>Guild traits are higher in decreased profiles</a:t>
+              <a:t>V2 guild traits are higher in decreased profiles</a:t>
             </a:r>
           </a:p>
         </p:txBody>
@@ -4397,19 +4981,19 @@
       </p:sp>
       <p:pic>
         <p:nvPicPr>
-          <p:cNvPr id="6" name=""/>
+          <p:cNvPr id="14" name="guild_trait_direction_shift"/>
           <p:cNvPicPr>
             <a:picLocks xmlns:a="http://schemas.openxmlformats.org/drawingml/2006/main" noChangeAspect="1"/>
           </p:cNvPicPr>
           <p:nvPr/>
         </p:nvPicPr>
         <p:blipFill>
-          <a:blip xmlns:r="http://schemas.openxmlformats.org/officeDocument/2006/relationships" xmlns:a="http://schemas.openxmlformats.org/drawingml/2006/main" r:embed="Rb8b4c852008d4e7c"/>
+          <a:blip xmlns:r="http://schemas.openxmlformats.org/officeDocument/2006/relationships" xmlns:a="http://schemas.openxmlformats.org/drawingml/2006/main" r:embed="Rbe114d1fbf9045a5"/>
           <a:stretch xmlns:a="http://schemas.openxmlformats.org/drawingml/2006/main"/>
         </p:blipFill>
         <p:spPr>
           <a:xfrm xmlns:a="http://schemas.openxmlformats.org/drawingml/2006/main">
-            <a:off x="1015093" y="1200150"/>
+            <a:off x="1034143" y="1200150"/>
             <a:ext cx="10123714" cy="5314950"/>
           </a:xfrm>
           <a:prstGeom xmlns:a="http://schemas.openxmlformats.org/drawingml/2006/main" prst="rect">
@@ -4458,6 +5042,7 @@
           <a:lstStyle xmlns:a="http://schemas.openxmlformats.org/drawingml/2006/main"/>
           <a:p xmlns:a="http://schemas.openxmlformats.org/drawingml/2006/main">
             <a:pPr algn="r">
+              <a:buNone/>
               <a:defRPr sz="975" b="0">
                 <a:solidFill>
                   <a:srgbClr val="64748B"/>
@@ -4476,7 +5061,7 @@
                 <a:ea typeface="Aptos"/>
                 <a:cs typeface="Aptos"/>
               </a:rPr>
-              <a:t>8/10</a:t>
+              <a:t>8/11</a:t>
             </a:r>
           </a:p>
         </p:txBody>
@@ -4614,6 +5199,7 @@
           <a:lstStyle xmlns:a="http://schemas.openxmlformats.org/drawingml/2006/main"/>
           <a:p xmlns:a="http://schemas.openxmlformats.org/drawingml/2006/main">
             <a:pPr algn="l">
+              <a:buNone/>
               <a:defRPr sz="1125" b="1">
                 <a:solidFill>
                   <a:srgbClr val="0F766E"/>
@@ -4632,7 +5218,7 @@
                 <a:ea typeface="Aptos"/>
                 <a:cs typeface="Aptos"/>
               </a:rPr>
-              <a:t>GUT ANAEROBE/FERMENTATION DEPLETION</a:t>
+              <a:t>GUT ANAEROBE V2 DEPLETION</a:t>
             </a:r>
           </a:p>
         </p:txBody>
@@ -4678,6 +5264,7 @@
           <a:lstStyle xmlns:a="http://schemas.openxmlformats.org/drawingml/2006/main"/>
           <a:p xmlns:a="http://schemas.openxmlformats.org/drawingml/2006/main">
             <a:pPr algn="l">
+              <a:buNone/>
               <a:defRPr sz="2025" b="1">
                 <a:solidFill>
                   <a:srgbClr val="0F172A"/>
@@ -4696,7 +5283,7 @@
                 <a:ea typeface="Aptos Display"/>
                 <a:cs typeface="Aptos Display"/>
               </a:rPr>
-              <a:t>Anatomical sites for decreased-profile gut anaerobe signal</a:t>
+              <a:t>Anatomical sites for decreased-profile gut anaerobe v2 signal</a:t>
             </a:r>
           </a:p>
         </p:txBody>
@@ -4736,20 +5323,20 @@
       </p:sp>
       <p:pic>
         <p:nvPicPr>
-          <p:cNvPr id="6" name=""/>
+          <p:cNvPr id="14" name="anatomical_sites_diagram"/>
           <p:cNvPicPr>
             <a:picLocks xmlns:a="http://schemas.openxmlformats.org/drawingml/2006/main" noChangeAspect="1"/>
           </p:cNvPicPr>
           <p:nvPr/>
         </p:nvPicPr>
         <p:blipFill>
-          <a:blip xmlns:r="http://schemas.openxmlformats.org/officeDocument/2006/relationships" xmlns:a="http://schemas.openxmlformats.org/drawingml/2006/main" r:embed="R0a0ad7f26d764a40"/>
+          <a:blip xmlns:r="http://schemas.openxmlformats.org/officeDocument/2006/relationships" xmlns:a="http://schemas.openxmlformats.org/drawingml/2006/main" r:embed="R5adae6cf98404e70"/>
           <a:stretch xmlns:a="http://schemas.openxmlformats.org/drawingml/2006/main"/>
         </p:blipFill>
         <p:spPr>
           <a:xfrm xmlns:a="http://schemas.openxmlformats.org/drawingml/2006/main">
-            <a:off x="3015239" y="1200150"/>
-            <a:ext cx="6123421" cy="5314950"/>
+            <a:off x="3013710" y="1200156"/>
+            <a:ext cx="6164580" cy="5314938"/>
           </a:xfrm>
           <a:prstGeom xmlns:a="http://schemas.openxmlformats.org/drawingml/2006/main" prst="rect">
             <a:avLst/>
@@ -4797,6 +5384,7 @@
           <a:lstStyle xmlns:a="http://schemas.openxmlformats.org/drawingml/2006/main"/>
           <a:p xmlns:a="http://schemas.openxmlformats.org/drawingml/2006/main">
             <a:pPr algn="r">
+              <a:buNone/>
               <a:defRPr sz="975" b="0">
                 <a:solidFill>
                   <a:srgbClr val="64748B"/>
@@ -4815,7 +5403,7 @@
                 <a:ea typeface="Aptos"/>
                 <a:cs typeface="Aptos"/>
               </a:rPr>
-              <a:t>9/10</a:t>
+              <a:t>9/11</a:t>
             </a:r>
           </a:p>
         </p:txBody>

</xml_diff>

<commit_message>
Update trait profile investigation outputs
</commit_message>
<xml_diff>
--- a/trait-visualization/trait-profile-investigation/trait_profile_investigation_figures.pptx
+++ b/trait-visualization/trait-profile-investigation/trait_profile_investigation_figures.pptx
@@ -2,23 +2,23 @@
 <file path=ppt/presentation.xml><?xml version="1.0" encoding="utf-8"?>
 <p:presentation xmlns:p="http://schemas.openxmlformats.org/presentationml/2006/main">
   <p:sldMasterIdLst>
-    <p:sldMasterId xmlns:r="http://schemas.openxmlformats.org/officeDocument/2006/relationships" id="2147483648" r:id="Rdc36e95add524681"/>
+    <p:sldMasterId xmlns:r="http://schemas.openxmlformats.org/officeDocument/2006/relationships" id="2147483648" r:id="Rb644bd47756a421e"/>
   </p:sldMasterIdLst>
   <p:notesMasterIdLst>
-    <p:notesMasterId xmlns:r="http://schemas.openxmlformats.org/officeDocument/2006/relationships" r:id="Rbc5dfe8ce93e4882"/>
+    <p:notesMasterId xmlns:r="http://schemas.openxmlformats.org/officeDocument/2006/relationships" r:id="R3c8c9a1074a94934"/>
   </p:notesMasterIdLst>
   <p:sldIdLst>
-    <p:sldId xmlns:r="http://schemas.openxmlformats.org/officeDocument/2006/relationships" id="256" r:id="Ra064f2cd4e094acb"/>
-    <p:sldId xmlns:r="http://schemas.openxmlformats.org/officeDocument/2006/relationships" id="257" r:id="R2764ec9049dd4200"/>
-    <p:sldId xmlns:r="http://schemas.openxmlformats.org/officeDocument/2006/relationships" id="258" r:id="Ra32b1c636f6042c6"/>
-    <p:sldId xmlns:r="http://schemas.openxmlformats.org/officeDocument/2006/relationships" id="259" r:id="R03cd14c4059845e0"/>
-    <p:sldId xmlns:r="http://schemas.openxmlformats.org/officeDocument/2006/relationships" id="260" r:id="R20d339ecef8247f5"/>
-    <p:sldId xmlns:r="http://schemas.openxmlformats.org/officeDocument/2006/relationships" id="261" r:id="R2696e3e83b134065"/>
-    <p:sldId xmlns:r="http://schemas.openxmlformats.org/officeDocument/2006/relationships" id="262" r:id="Rbd357faf471e4dbe"/>
-    <p:sldId xmlns:r="http://schemas.openxmlformats.org/officeDocument/2006/relationships" id="263" r:id="Ra685c171f9b741ce"/>
-    <p:sldId xmlns:r="http://schemas.openxmlformats.org/officeDocument/2006/relationships" id="264" r:id="R6de2e6eab7e84948"/>
-    <p:sldId xmlns:r="http://schemas.openxmlformats.org/officeDocument/2006/relationships" id="265" r:id="Rffc8da5f8702435c"/>
-    <p:sldId xmlns:r="http://schemas.openxmlformats.org/officeDocument/2006/relationships" id="266" r:id="Rb3f5974e302e4bbc"/>
+    <p:sldId xmlns:r="http://schemas.openxmlformats.org/officeDocument/2006/relationships" id="256" r:id="Rbfc58da720d648da"/>
+    <p:sldId xmlns:r="http://schemas.openxmlformats.org/officeDocument/2006/relationships" id="257" r:id="R8f2ac862138042e5"/>
+    <p:sldId xmlns:r="http://schemas.openxmlformats.org/officeDocument/2006/relationships" id="258" r:id="Rd3b25f4c09ee47e2"/>
+    <p:sldId xmlns:r="http://schemas.openxmlformats.org/officeDocument/2006/relationships" id="259" r:id="R3ea2429faee64daf"/>
+    <p:sldId xmlns:r="http://schemas.openxmlformats.org/officeDocument/2006/relationships" id="260" r:id="Re6426ad2094948ee"/>
+    <p:sldId xmlns:r="http://schemas.openxmlformats.org/officeDocument/2006/relationships" id="261" r:id="Rdef2e4d414e242ac"/>
+    <p:sldId xmlns:r="http://schemas.openxmlformats.org/officeDocument/2006/relationships" id="262" r:id="Rb8186928d7da4ec3"/>
+    <p:sldId xmlns:r="http://schemas.openxmlformats.org/officeDocument/2006/relationships" id="263" r:id="R008c946eb3ca4790"/>
+    <p:sldId xmlns:r="http://schemas.openxmlformats.org/officeDocument/2006/relationships" id="264" r:id="Rf2e96244434c47c9"/>
+    <p:sldId xmlns:r="http://schemas.openxmlformats.org/officeDocument/2006/relationships" id="265" r:id="R9f87991bfc724d2a"/>
+    <p:sldId xmlns:r="http://schemas.openxmlformats.org/officeDocument/2006/relationships" id="266" r:id="R232fba94521d4791"/>
   </p:sldIdLst>
   <p:sldSz cx="12192000" cy="6858000"/>
   <p:notesSz cx="6858000" cy="9144000"/>
@@ -1225,7 +1225,7 @@
   </p:cSld>
   <p:clrMap bg1="lt1" tx1="dk1" bg2="lt2" tx2="dk2" accent1="accent1" accent2="accent2" accent3="accent3" accent4="accent4" accent5="accent5" accent6="accent6" hlink="hlink" folHlink="folHlink"/>
   <p:sldLayoutIdLst>
-    <p:sldLayoutId xmlns:r="http://schemas.openxmlformats.org/officeDocument/2006/relationships" id="2147483649" r:id="Rb7687baf2a604a5d"/>
+    <p:sldLayoutId xmlns:r="http://schemas.openxmlformats.org/officeDocument/2006/relationships" id="2147483649" r:id="R5258170e21314083"/>
   </p:sldLayoutIdLst>
   <p:txStyles>
     <p:titleStyle>
@@ -1960,11 +1960,11 @@
           <p:nvPr/>
         </p:nvPicPr>
         <p:blipFill>
-          <a:blip xmlns:r="http://schemas.openxmlformats.org/officeDocument/2006/relationships" xmlns:a="http://schemas.openxmlformats.org/drawingml/2006/main" r:embed="Rf16c365c3eb741ef"/>
+          <a:blip xmlns:r="http://schemas.openxmlformats.org/officeDocument/2006/relationships" xmlns:a="http://schemas.openxmlformats.org/drawingml/2006/main" r:embed="Rb6c7547901e84c4b"/>
           <a:stretch xmlns:a="http://schemas.openxmlformats.org/drawingml/2006/main"/>
         </p:blipFill>
         <p:spPr>
-          <a:xfrm xmlns:a="http://schemas.openxmlformats.org/drawingml/2006/main">
+          <a:xfrm xmlns:a="http://schemas.openxmlformats.org/drawingml/2006/main" flipH="0" flipV="0">
             <a:off x="1666875" y="1200150"/>
             <a:ext cx="8858250" cy="5314950"/>
           </a:xfrm>
@@ -2190,7 +2190,7 @@
                 <a:ea typeface="Aptos"/>
                 <a:cs typeface="Aptos"/>
               </a:rPr>
-              <a:t>GUT ANAEROBE V2 DEPLETION</a:t>
+              <a:t>ANAEROBE V2 DEPLETION SIGNAL</a:t>
             </a:r>
           </a:p>
         </p:txBody>
@@ -2302,11 +2302,11 @@
           <p:nvPr/>
         </p:nvPicPr>
         <p:blipFill>
-          <a:blip xmlns:r="http://schemas.openxmlformats.org/officeDocument/2006/relationships" xmlns:a="http://schemas.openxmlformats.org/drawingml/2006/main" r:embed="Re1d950abae3c47b7"/>
+          <a:blip xmlns:r="http://schemas.openxmlformats.org/officeDocument/2006/relationships" xmlns:a="http://schemas.openxmlformats.org/drawingml/2006/main" r:embed="R4f0b484d8d75453e"/>
           <a:stretch xmlns:a="http://schemas.openxmlformats.org/drawingml/2006/main"/>
         </p:blipFill>
         <p:spPr>
-          <a:xfrm xmlns:a="http://schemas.openxmlformats.org/drawingml/2006/main">
+          <a:xfrm xmlns:a="http://schemas.openxmlformats.org/drawingml/2006/main" flipH="0" flipV="0">
             <a:off x="2304308" y="1200150"/>
             <a:ext cx="7583479" cy="5314950"/>
           </a:xfrm>
@@ -2659,11 +2659,11 @@
           <p:nvPr/>
         </p:nvPicPr>
         <p:blipFill>
-          <a:blip xmlns:r="http://schemas.openxmlformats.org/officeDocument/2006/relationships" xmlns:a="http://schemas.openxmlformats.org/drawingml/2006/main" r:embed="R16fa5d5ec13646d5"/>
+          <a:blip xmlns:r="http://schemas.openxmlformats.org/officeDocument/2006/relationships" xmlns:a="http://schemas.openxmlformats.org/drawingml/2006/main" r:embed="R41ca96f3d6ce42bf"/>
           <a:stretch xmlns:a="http://schemas.openxmlformats.org/drawingml/2006/main"/>
         </p:blipFill>
         <p:spPr>
-          <a:xfrm xmlns:a="http://schemas.openxmlformats.org/drawingml/2006/main">
+          <a:xfrm xmlns:a="http://schemas.openxmlformats.org/drawingml/2006/main" flipH="0" flipV="0">
             <a:off x="381000" y="819150"/>
             <a:ext cx="11430000" cy="5715000"/>
           </a:xfrm>
@@ -2936,11 +2936,11 @@
           <p:nvPr/>
         </p:nvPicPr>
         <p:blipFill>
-          <a:blip xmlns:r="http://schemas.openxmlformats.org/officeDocument/2006/relationships" xmlns:a="http://schemas.openxmlformats.org/drawingml/2006/main" r:embed="Rb86cd14e596e45f7"/>
+          <a:blip xmlns:r="http://schemas.openxmlformats.org/officeDocument/2006/relationships" xmlns:a="http://schemas.openxmlformats.org/drawingml/2006/main" r:embed="R86cd08427d934510"/>
           <a:stretch xmlns:a="http://schemas.openxmlformats.org/drawingml/2006/main"/>
         </p:blipFill>
         <p:spPr>
-          <a:xfrm xmlns:a="http://schemas.openxmlformats.org/drawingml/2006/main">
+          <a:xfrm xmlns:a="http://schemas.openxmlformats.org/drawingml/2006/main" flipH="0" flipV="0">
             <a:off x="781050" y="1200150"/>
             <a:ext cx="10629900" cy="5314950"/>
           </a:xfrm>
@@ -3278,11 +3278,11 @@
           <p:nvPr/>
         </p:nvPicPr>
         <p:blipFill>
-          <a:blip xmlns:r="http://schemas.openxmlformats.org/officeDocument/2006/relationships" xmlns:a="http://schemas.openxmlformats.org/drawingml/2006/main" r:embed="Rf3db00a0e7d34006"/>
+          <a:blip xmlns:r="http://schemas.openxmlformats.org/officeDocument/2006/relationships" xmlns:a="http://schemas.openxmlformats.org/drawingml/2006/main" r:embed="R285addeb4c574327"/>
           <a:stretch xmlns:a="http://schemas.openxmlformats.org/drawingml/2006/main"/>
         </p:blipFill>
         <p:spPr>
-          <a:xfrm xmlns:a="http://schemas.openxmlformats.org/drawingml/2006/main">
+          <a:xfrm xmlns:a="http://schemas.openxmlformats.org/drawingml/2006/main" flipH="0" flipV="0">
             <a:off x="1264275" y="1200150"/>
             <a:ext cx="9663545" cy="5314950"/>
           </a:xfrm>
@@ -3620,11 +3620,11 @@
           <p:nvPr/>
         </p:nvPicPr>
         <p:blipFill>
-          <a:blip xmlns:r="http://schemas.openxmlformats.org/officeDocument/2006/relationships" xmlns:a="http://schemas.openxmlformats.org/drawingml/2006/main" r:embed="R078adfba46cf408a"/>
+          <a:blip xmlns:r="http://schemas.openxmlformats.org/officeDocument/2006/relationships" xmlns:a="http://schemas.openxmlformats.org/drawingml/2006/main" r:embed="R03b7f3fce99e44be"/>
           <a:stretch xmlns:a="http://schemas.openxmlformats.org/drawingml/2006/main"/>
         </p:blipFill>
         <p:spPr>
-          <a:xfrm xmlns:a="http://schemas.openxmlformats.org/drawingml/2006/main">
+          <a:xfrm xmlns:a="http://schemas.openxmlformats.org/drawingml/2006/main" flipH="0" flipV="0">
             <a:off x="1137299" y="1200150"/>
             <a:ext cx="9917498" cy="5314950"/>
           </a:xfrm>
@@ -3962,11 +3962,11 @@
           <p:nvPr/>
         </p:nvPicPr>
         <p:blipFill>
-          <a:blip xmlns:r="http://schemas.openxmlformats.org/officeDocument/2006/relationships" xmlns:a="http://schemas.openxmlformats.org/drawingml/2006/main" r:embed="R5e18407430e44cd9"/>
+          <a:blip xmlns:r="http://schemas.openxmlformats.org/officeDocument/2006/relationships" xmlns:a="http://schemas.openxmlformats.org/drawingml/2006/main" r:embed="R33cebe98bbc949aa"/>
           <a:stretch xmlns:a="http://schemas.openxmlformats.org/drawingml/2006/main"/>
         </p:blipFill>
         <p:spPr>
-          <a:xfrm xmlns:a="http://schemas.openxmlformats.org/drawingml/2006/main">
+          <a:xfrm xmlns:a="http://schemas.openxmlformats.org/drawingml/2006/main" flipH="0" flipV="0">
             <a:off x="2306193" y="1200162"/>
             <a:ext cx="7579614" cy="5314927"/>
           </a:xfrm>
@@ -4192,7 +4192,7 @@
                 <a:ea typeface="Aptos"/>
                 <a:cs typeface="Aptos"/>
               </a:rPr>
-              <a:t>GUT ANAEROBE V2 DEPLETION</a:t>
+              <a:t>ANAEROBE V2 DEPLETION SIGNAL</a:t>
             </a:r>
           </a:p>
         </p:txBody>
@@ -4304,11 +4304,11 @@
           <p:nvPr/>
         </p:nvPicPr>
         <p:blipFill>
-          <a:blip xmlns:r="http://schemas.openxmlformats.org/officeDocument/2006/relationships" xmlns:a="http://schemas.openxmlformats.org/drawingml/2006/main" r:embed="Raddd61b6de084da8"/>
+          <a:blip xmlns:r="http://schemas.openxmlformats.org/officeDocument/2006/relationships" xmlns:a="http://schemas.openxmlformats.org/drawingml/2006/main" r:embed="Ra5d3396c2f9943f4"/>
           <a:stretch xmlns:a="http://schemas.openxmlformats.org/drawingml/2006/main"/>
         </p:blipFill>
         <p:spPr>
-          <a:xfrm xmlns:a="http://schemas.openxmlformats.org/drawingml/2006/main">
+          <a:xfrm xmlns:a="http://schemas.openxmlformats.org/drawingml/2006/main" flipH="0" flipV="0">
             <a:off x="1113282" y="1200150"/>
             <a:ext cx="9965531" cy="5314950"/>
           </a:xfrm>
@@ -4534,7 +4534,7 @@
                 <a:ea typeface="Aptos"/>
                 <a:cs typeface="Aptos"/>
               </a:rPr>
-              <a:t>GUT ANAEROBE V2 DEPLETION</a:t>
+              <a:t>ANAEROBE V2 DEPLETION SIGNAL</a:t>
             </a:r>
           </a:p>
         </p:txBody>
@@ -4599,7 +4599,7 @@
                 <a:ea typeface="Aptos Display"/>
                 <a:cs typeface="Aptos Display"/>
               </a:rPr>
-              <a:t>Conditions with high decreased-profile gut anaerobe v2 guild signal</a:t>
+              <a:t>Conditions with high decreased-profile anaerobe v2 guild signal</a:t>
             </a:r>
           </a:p>
         </p:txBody>
@@ -4646,11 +4646,11 @@
           <p:nvPr/>
         </p:nvPicPr>
         <p:blipFill>
-          <a:blip xmlns:r="http://schemas.openxmlformats.org/officeDocument/2006/relationships" xmlns:a="http://schemas.openxmlformats.org/drawingml/2006/main" r:embed="R15695ae655714ca2"/>
+          <a:blip xmlns:r="http://schemas.openxmlformats.org/officeDocument/2006/relationships" xmlns:a="http://schemas.openxmlformats.org/drawingml/2006/main" r:embed="Rf51dc2ad4aec4997"/>
           <a:stretch xmlns:a="http://schemas.openxmlformats.org/drawingml/2006/main"/>
         </p:blipFill>
         <p:spPr>
-          <a:xfrm xmlns:a="http://schemas.openxmlformats.org/drawingml/2006/main">
+          <a:xfrm xmlns:a="http://schemas.openxmlformats.org/drawingml/2006/main" flipH="0" flipV="0">
             <a:off x="781050" y="1200150"/>
             <a:ext cx="10629900" cy="5314950"/>
           </a:xfrm>
@@ -4876,7 +4876,7 @@
                 <a:ea typeface="Aptos"/>
                 <a:cs typeface="Aptos"/>
               </a:rPr>
-              <a:t>GUT ANAEROBE V2 DEPLETION</a:t>
+              <a:t>ANAEROBE V2 DEPLETION SIGNAL</a:t>
             </a:r>
           </a:p>
         </p:txBody>
@@ -4988,11 +4988,11 @@
           <p:nvPr/>
         </p:nvPicPr>
         <p:blipFill>
-          <a:blip xmlns:r="http://schemas.openxmlformats.org/officeDocument/2006/relationships" xmlns:a="http://schemas.openxmlformats.org/drawingml/2006/main" r:embed="Rbe114d1fbf9045a5"/>
+          <a:blip xmlns:r="http://schemas.openxmlformats.org/officeDocument/2006/relationships" xmlns:a="http://schemas.openxmlformats.org/drawingml/2006/main" r:embed="R8c8e1596f0f24c05"/>
           <a:stretch xmlns:a="http://schemas.openxmlformats.org/drawingml/2006/main"/>
         </p:blipFill>
         <p:spPr>
-          <a:xfrm xmlns:a="http://schemas.openxmlformats.org/drawingml/2006/main">
+          <a:xfrm xmlns:a="http://schemas.openxmlformats.org/drawingml/2006/main" flipH="0" flipV="0">
             <a:off x="1034143" y="1200150"/>
             <a:ext cx="10123714" cy="5314950"/>
           </a:xfrm>
@@ -5218,7 +5218,7 @@
                 <a:ea typeface="Aptos"/>
                 <a:cs typeface="Aptos"/>
               </a:rPr>
-              <a:t>GUT ANAEROBE V2 DEPLETION</a:t>
+              <a:t>ANAEROBE V2 DEPLETION SIGNAL</a:t>
             </a:r>
           </a:p>
         </p:txBody>
@@ -5283,7 +5283,7 @@
                 <a:ea typeface="Aptos Display"/>
                 <a:cs typeface="Aptos Display"/>
               </a:rPr>
-              <a:t>Anatomical sites for decreased-profile gut anaerobe v2 signal</a:t>
+              <a:t>Anatomical sites for decreased-profile anaerobe v2 signal</a:t>
             </a:r>
           </a:p>
         </p:txBody>
@@ -5330,11 +5330,11 @@
           <p:nvPr/>
         </p:nvPicPr>
         <p:blipFill>
-          <a:blip xmlns:r="http://schemas.openxmlformats.org/officeDocument/2006/relationships" xmlns:a="http://schemas.openxmlformats.org/drawingml/2006/main" r:embed="R5adae6cf98404e70"/>
+          <a:blip xmlns:r="http://schemas.openxmlformats.org/officeDocument/2006/relationships" xmlns:a="http://schemas.openxmlformats.org/drawingml/2006/main" r:embed="Rce00ef0e5c6b441a"/>
           <a:stretch xmlns:a="http://schemas.openxmlformats.org/drawingml/2006/main"/>
         </p:blipFill>
         <p:spPr>
-          <a:xfrm xmlns:a="http://schemas.openxmlformats.org/drawingml/2006/main">
+          <a:xfrm xmlns:a="http://schemas.openxmlformats.org/drawingml/2006/main" flipH="0" flipV="0">
             <a:off x="3013710" y="1200156"/>
             <a:ext cx="6164580" cy="5314938"/>
           </a:xfrm>

</xml_diff>

<commit_message>
Add stacked target taxa charts to trait profile deck
</commit_message>
<xml_diff>
--- a/trait-visualization/trait-profile-investigation/trait_profile_investigation_figures.pptx
+++ b/trait-visualization/trait-profile-investigation/trait_profile_investigation_figures.pptx
@@ -1,121 +1,123 @@
 
 <file path=ppt/presentation.xml><?xml version="1.0" encoding="utf-8"?>
-<p:presentation xmlns:p="http://schemas.openxmlformats.org/presentationml/2006/main">
+<p:presentation xmlns:ns2="http://schemas.openxmlformats.org/drawingml/2006/main" xmlns:p="http://schemas.openxmlformats.org/presentationml/2006/main" xmlns:r="http://schemas.openxmlformats.org/officeDocument/2006/relationships">
   <p:sldMasterIdLst>
-    <p:sldMasterId xmlns:r="http://schemas.openxmlformats.org/officeDocument/2006/relationships" id="2147483648" r:id="Rb644bd47756a421e"/>
+    <p:sldMasterId id="2147483648" r:id="Rb644bd47756a421e"/>
   </p:sldMasterIdLst>
   <p:notesMasterIdLst>
-    <p:notesMasterId xmlns:r="http://schemas.openxmlformats.org/officeDocument/2006/relationships" r:id="R3c8c9a1074a94934"/>
+    <p:notesMasterId r:id="R3c8c9a1074a94934"/>
   </p:notesMasterIdLst>
   <p:sldIdLst>
-    <p:sldId xmlns:r="http://schemas.openxmlformats.org/officeDocument/2006/relationships" id="256" r:id="Rbfc58da720d648da"/>
-    <p:sldId xmlns:r="http://schemas.openxmlformats.org/officeDocument/2006/relationships" id="257" r:id="R8f2ac862138042e5"/>
-    <p:sldId xmlns:r="http://schemas.openxmlformats.org/officeDocument/2006/relationships" id="258" r:id="Rd3b25f4c09ee47e2"/>
-    <p:sldId xmlns:r="http://schemas.openxmlformats.org/officeDocument/2006/relationships" id="259" r:id="R3ea2429faee64daf"/>
-    <p:sldId xmlns:r="http://schemas.openxmlformats.org/officeDocument/2006/relationships" id="260" r:id="Re6426ad2094948ee"/>
-    <p:sldId xmlns:r="http://schemas.openxmlformats.org/officeDocument/2006/relationships" id="261" r:id="Rdef2e4d414e242ac"/>
-    <p:sldId xmlns:r="http://schemas.openxmlformats.org/officeDocument/2006/relationships" id="262" r:id="Rb8186928d7da4ec3"/>
-    <p:sldId xmlns:r="http://schemas.openxmlformats.org/officeDocument/2006/relationships" id="263" r:id="R008c946eb3ca4790"/>
-    <p:sldId xmlns:r="http://schemas.openxmlformats.org/officeDocument/2006/relationships" id="264" r:id="Rf2e96244434c47c9"/>
-    <p:sldId xmlns:r="http://schemas.openxmlformats.org/officeDocument/2006/relationships" id="265" r:id="R9f87991bfc724d2a"/>
-    <p:sldId xmlns:r="http://schemas.openxmlformats.org/officeDocument/2006/relationships" id="266" r:id="R232fba94521d4791"/>
+    <p:sldId id="256" r:id="Rbfc58da720d648da"/>
+    <p:sldId id="257" r:id="R8f2ac862138042e5"/>
+    <p:sldId id="258" r:id="Rd3b25f4c09ee47e2"/>
+    <p:sldId id="259" r:id="R3ea2429faee64daf"/>
+    <p:sldId id="260" r:id="Re6426ad2094948ee"/>
+    <p:sldId id="267" r:id="RfacultativeStackedTaxaSlide"/>
+    <p:sldId id="261" r:id="Rdef2e4d414e242ac"/>
+    <p:sldId id="262" r:id="Rb8186928d7da4ec3"/>
+    <p:sldId id="263" r:id="R008c946eb3ca4790"/>
+    <p:sldId id="264" r:id="Rf2e96244434c47c9"/>
+    <p:sldId id="265" r:id="R9f87991bfc724d2a"/>
+    <p:sldId id="268" r:id="RanaerobeStackedTaxaSlide"/>
+    <p:sldId id="266" r:id="R232fba94521d4791"/>
   </p:sldIdLst>
   <p:sldSz cx="12192000" cy="6858000"/>
   <p:notesSz cx="6858000" cy="9144000"/>
   <p:defaultTextStyle>
-    <a:defPPr xmlns:a="http://schemas.openxmlformats.org/drawingml/2006/main">
-      <a:defRPr lang="en-US"/>
-    </a:defPPr>
-    <a:lvl1pPr xmlns:a="http://schemas.openxmlformats.org/drawingml/2006/main" marL="0" indent="0" algn="l" defTabSz="914400">
-      <a:defRPr sz="1800" kern="1200">
-        <a:solidFill>
-          <a:schemeClr val="tx1"/>
-        </a:solidFill>
-        <a:latin typeface="+mn-lt"/>
-        <a:ea typeface="+mn-ea"/>
-        <a:cs typeface="+mn-cs"/>
-      </a:defRPr>
-    </a:lvl1pPr>
-    <a:lvl2pPr xmlns:a="http://schemas.openxmlformats.org/drawingml/2006/main" marL="457200" indent="0" algn="l" defTabSz="914400">
-      <a:defRPr sz="1800" kern="1200">
-        <a:solidFill>
-          <a:schemeClr val="tx1"/>
-        </a:solidFill>
-        <a:latin typeface="+mn-lt"/>
-        <a:ea typeface="+mn-ea"/>
-        <a:cs typeface="+mn-cs"/>
-      </a:defRPr>
-    </a:lvl2pPr>
-    <a:lvl3pPr xmlns:a="http://schemas.openxmlformats.org/drawingml/2006/main" marL="914400" indent="0" algn="l" defTabSz="914400">
-      <a:defRPr sz="1800" kern="1200">
-        <a:solidFill>
-          <a:schemeClr val="tx1"/>
-        </a:solidFill>
-        <a:latin typeface="+mn-lt"/>
-        <a:ea typeface="+mn-ea"/>
-        <a:cs typeface="+mn-cs"/>
-      </a:defRPr>
-    </a:lvl3pPr>
-    <a:lvl4pPr xmlns:a="http://schemas.openxmlformats.org/drawingml/2006/main" marL="1371600" indent="0" algn="l" defTabSz="914400">
-      <a:defRPr sz="1800" kern="1200">
-        <a:solidFill>
-          <a:schemeClr val="tx1"/>
-        </a:solidFill>
-        <a:latin typeface="+mn-lt"/>
-        <a:ea typeface="+mn-ea"/>
-        <a:cs typeface="+mn-cs"/>
-      </a:defRPr>
-    </a:lvl4pPr>
-    <a:lvl5pPr xmlns:a="http://schemas.openxmlformats.org/drawingml/2006/main" marL="1828800" indent="0" algn="l" defTabSz="914400">
-      <a:defRPr sz="1800" kern="1200">
-        <a:solidFill>
-          <a:schemeClr val="tx1"/>
-        </a:solidFill>
-        <a:latin typeface="+mn-lt"/>
-        <a:ea typeface="+mn-ea"/>
-        <a:cs typeface="+mn-cs"/>
-      </a:defRPr>
-    </a:lvl5pPr>
-    <a:lvl6pPr xmlns:a="http://schemas.openxmlformats.org/drawingml/2006/main" marL="2286000" indent="0" algn="l" defTabSz="914400">
-      <a:defRPr sz="1800" kern="1200">
-        <a:solidFill>
-          <a:schemeClr val="tx1"/>
-        </a:solidFill>
-        <a:latin typeface="+mn-lt"/>
-        <a:ea typeface="+mn-ea"/>
-        <a:cs typeface="+mn-cs"/>
-      </a:defRPr>
-    </a:lvl6pPr>
-    <a:lvl7pPr xmlns:a="http://schemas.openxmlformats.org/drawingml/2006/main" marL="2743200" indent="0" algn="l" defTabSz="914400">
-      <a:defRPr sz="1800" kern="1200">
-        <a:solidFill>
-          <a:schemeClr val="tx1"/>
-        </a:solidFill>
-        <a:latin typeface="+mn-lt"/>
-        <a:ea typeface="+mn-ea"/>
-        <a:cs typeface="+mn-cs"/>
-      </a:defRPr>
-    </a:lvl7pPr>
-    <a:lvl8pPr xmlns:a="http://schemas.openxmlformats.org/drawingml/2006/main" marL="3200400" indent="0" algn="l" defTabSz="914400">
-      <a:defRPr sz="1800" kern="1200">
-        <a:solidFill>
-          <a:schemeClr val="tx1"/>
-        </a:solidFill>
-        <a:latin typeface="+mn-lt"/>
-        <a:ea typeface="+mn-ea"/>
-        <a:cs typeface="+mn-cs"/>
-      </a:defRPr>
-    </a:lvl8pPr>
-    <a:lvl9pPr xmlns:a="http://schemas.openxmlformats.org/drawingml/2006/main" marL="3657600" indent="0" algn="l" defTabSz="914400">
-      <a:defRPr sz="1800" kern="1200">
-        <a:solidFill>
-          <a:schemeClr val="tx1"/>
-        </a:solidFill>
-        <a:latin typeface="+mn-lt"/>
-        <a:ea typeface="+mn-ea"/>
-        <a:cs typeface="+mn-cs"/>
-      </a:defRPr>
-    </a:lvl9pPr>
+    <ns2:defPPr>
+      <ns2:defRPr lang="en-US"/>
+    </ns2:defPPr>
+    <ns2:lvl1pPr marL="0" indent="0" algn="l" defTabSz="914400">
+      <ns2:defRPr sz="1800" kern="1200">
+        <ns2:solidFill>
+          <ns2:schemeClr val="tx1"/>
+        </ns2:solidFill>
+        <ns2:latin typeface="+mn-lt"/>
+        <ns2:ea typeface="+mn-ea"/>
+        <ns2:cs typeface="+mn-cs"/>
+      </ns2:defRPr>
+    </ns2:lvl1pPr>
+    <ns2:lvl2pPr marL="457200" indent="0" algn="l" defTabSz="914400">
+      <ns2:defRPr sz="1800" kern="1200">
+        <ns2:solidFill>
+          <ns2:schemeClr val="tx1"/>
+        </ns2:solidFill>
+        <ns2:latin typeface="+mn-lt"/>
+        <ns2:ea typeface="+mn-ea"/>
+        <ns2:cs typeface="+mn-cs"/>
+      </ns2:defRPr>
+    </ns2:lvl2pPr>
+    <ns2:lvl3pPr marL="914400" indent="0" algn="l" defTabSz="914400">
+      <ns2:defRPr sz="1800" kern="1200">
+        <ns2:solidFill>
+          <ns2:schemeClr val="tx1"/>
+        </ns2:solidFill>
+        <ns2:latin typeface="+mn-lt"/>
+        <ns2:ea typeface="+mn-ea"/>
+        <ns2:cs typeface="+mn-cs"/>
+      </ns2:defRPr>
+    </ns2:lvl3pPr>
+    <ns2:lvl4pPr marL="1371600" indent="0" algn="l" defTabSz="914400">
+      <ns2:defRPr sz="1800" kern="1200">
+        <ns2:solidFill>
+          <ns2:schemeClr val="tx1"/>
+        </ns2:solidFill>
+        <ns2:latin typeface="+mn-lt"/>
+        <ns2:ea typeface="+mn-ea"/>
+        <ns2:cs typeface="+mn-cs"/>
+      </ns2:defRPr>
+    </ns2:lvl4pPr>
+    <ns2:lvl5pPr marL="1828800" indent="0" algn="l" defTabSz="914400">
+      <ns2:defRPr sz="1800" kern="1200">
+        <ns2:solidFill>
+          <ns2:schemeClr val="tx1"/>
+        </ns2:solidFill>
+        <ns2:latin typeface="+mn-lt"/>
+        <ns2:ea typeface="+mn-ea"/>
+        <ns2:cs typeface="+mn-cs"/>
+      </ns2:defRPr>
+    </ns2:lvl5pPr>
+    <ns2:lvl6pPr marL="2286000" indent="0" algn="l" defTabSz="914400">
+      <ns2:defRPr sz="1800" kern="1200">
+        <ns2:solidFill>
+          <ns2:schemeClr val="tx1"/>
+        </ns2:solidFill>
+        <ns2:latin typeface="+mn-lt"/>
+        <ns2:ea typeface="+mn-ea"/>
+        <ns2:cs typeface="+mn-cs"/>
+      </ns2:defRPr>
+    </ns2:lvl6pPr>
+    <ns2:lvl7pPr marL="2743200" indent="0" algn="l" defTabSz="914400">
+      <ns2:defRPr sz="1800" kern="1200">
+        <ns2:solidFill>
+          <ns2:schemeClr val="tx1"/>
+        </ns2:solidFill>
+        <ns2:latin typeface="+mn-lt"/>
+        <ns2:ea typeface="+mn-ea"/>
+        <ns2:cs typeface="+mn-cs"/>
+      </ns2:defRPr>
+    </ns2:lvl7pPr>
+    <ns2:lvl8pPr marL="3200400" indent="0" algn="l" defTabSz="914400">
+      <ns2:defRPr sz="1800" kern="1200">
+        <ns2:solidFill>
+          <ns2:schemeClr val="tx1"/>
+        </ns2:solidFill>
+        <ns2:latin typeface="+mn-lt"/>
+        <ns2:ea typeface="+mn-ea"/>
+        <ns2:cs typeface="+mn-cs"/>
+      </ns2:defRPr>
+    </ns2:lvl8pPr>
+    <ns2:lvl9pPr marL="3657600" indent="0" algn="l" defTabSz="914400">
+      <ns2:defRPr sz="1800" kern="1200">
+        <ns2:solidFill>
+          <ns2:schemeClr val="tx1"/>
+        </ns2:solidFill>
+        <ns2:latin typeface="+mn-lt"/>
+        <ns2:ea typeface="+mn-ea"/>
+        <ns2:cs typeface="+mn-cs"/>
+      </ns2:defRPr>
+    </ns2:lvl9pPr>
   </p:defaultTextStyle>
 </p:presentation>
 </file>
@@ -2033,7 +2035,7 @@
                 <a:ea typeface="Aptos"/>
                 <a:cs typeface="Aptos"/>
               </a:rPr>
-              <a:t>1/11</a:t>
+              <a:t>1/13</a:t>
             </a:r>
           </a:p>
         </p:txBody>
@@ -2375,7 +2377,7 @@
                 <a:ea typeface="Aptos"/>
                 <a:cs typeface="Aptos"/>
               </a:rPr>
-              <a:t>10/11</a:t>
+              <a:t>11/13</a:t>
             </a:r>
           </a:p>
         </p:txBody>
@@ -2612,7 +2614,7 @@
                   <a:srgbClr val="64748B"/>
                 </a:solidFill>
               </a:rPr>
-              <a:t>11/11</a:t>
+              <a:t>13/13</a:t>
             </a:r>
           </a:p>
         </p:txBody>
@@ -2676,6 +2678,690 @@
     <p:extLst>
       <p:ext uri="{BB962C8B-B14F-4D97-AF65-F5344CB8AC3E}">
         <p14:creationId xmlns:p14="http://schemas.microsoft.com/office/powerpoint/2010/main" val="1263696544"/>
+      </p:ext>
+    </p:extLst>
+  </p:cSld>
+</p:sld>
+</file>
+
+<file path=ppt/slides/slide12.xml><?xml version="1.0" encoding="utf-8"?>
+<p:sld xmlns:p="http://schemas.openxmlformats.org/presentationml/2006/main">
+  <p:cSld>
+    <p:spTree>
+      <p:nvGrpSpPr>
+        <p:cNvPr id="1" name=""/>
+        <p:cNvGrpSpPr/>
+        <p:nvPr/>
+      </p:nvGrpSpPr>
+      <p:grpSpPr>
+        <a:xfrm xmlns:a="http://schemas.openxmlformats.org/drawingml/2006/main"/>
+      </p:grpSpPr>
+      <p:sp>
+        <p:nvSpPr>
+          <p:cNvPr id="1" name="">
+            <a:extLst xmlns:a="http://schemas.openxmlformats.org/drawingml/2006/main">
+              <a:ext uri="{FF2B5EF4-FFF2-40B4-BE49-F238E27FC236}">
+                <a16:creationId xmlns:a16="http://schemas.microsoft.com/office/drawing/2014/main" id="{2EC5C1E7-FB24-4386-A50F-4A6419DB91E2}"/>
+              </a:ext>
+            </a:extLst>
+          </p:cNvPr>
+          <p:cNvSpPr>
+            <a:spLocks xmlns:a="http://schemas.openxmlformats.org/drawingml/2006/main" noGrp="1"/>
+          </p:cNvSpPr>
+          <p:nvPr/>
+        </p:nvSpPr>
+        <p:spPr>
+          <a:xfrm xmlns:a="http://schemas.openxmlformats.org/drawingml/2006/main">
+            <a:off x="0" y="0"/>
+            <a:ext cx="12192000" cy="6858000"/>
+          </a:xfrm>
+          <a:prstGeom xmlns:a="http://schemas.openxmlformats.org/drawingml/2006/main" prst="rect">
+            <a:avLst/>
+          </a:prstGeom>
+          <a:solidFill xmlns:a="http://schemas.openxmlformats.org/drawingml/2006/main">
+            <a:srgbClr val="F8FAFC"/>
+          </a:solidFill>
+          <a:ln xmlns:a="http://schemas.openxmlformats.org/drawingml/2006/main" w="0">
+            <a:solidFill>
+              <a:srgbClr val="000000">
+                <a:alpha val="0"/>
+              </a:srgbClr>
+            </a:solidFill>
+            <a:prstDash val="solid"/>
+          </a:ln>
+        </p:spPr>
+      </p:sp>
+      <p:sp>
+        <p:nvSpPr>
+          <p:cNvPr id="2" name="">
+            <a:extLst xmlns:a="http://schemas.openxmlformats.org/drawingml/2006/main">
+              <a:ext uri="{FF2B5EF4-FFF2-40B4-BE49-F238E27FC236}">
+                <a16:creationId xmlns:a16="http://schemas.microsoft.com/office/drawing/2014/main" id="{F8E6CBA3-1380-471A-B2AC-34A971F5CC63}"/>
+              </a:ext>
+            </a:extLst>
+          </p:cNvPr>
+          <p:cNvSpPr>
+            <a:spLocks xmlns:a="http://schemas.openxmlformats.org/drawingml/2006/main" noGrp="1"/>
+          </p:cNvSpPr>
+          <p:nvPr/>
+        </p:nvSpPr>
+        <p:spPr>
+          <a:xfrm xmlns:a="http://schemas.openxmlformats.org/drawingml/2006/main">
+            <a:off x="0" y="0"/>
+            <a:ext cx="12192000" cy="57150"/>
+          </a:xfrm>
+          <a:prstGeom xmlns:a="http://schemas.openxmlformats.org/drawingml/2006/main" prst="rect">
+            <a:avLst/>
+          </a:prstGeom>
+          <a:solidFill xmlns:a="http://schemas.openxmlformats.org/drawingml/2006/main">
+            <a:srgbClr val="2563EB"/>
+          </a:solidFill>
+          <a:ln xmlns:a="http://schemas.openxmlformats.org/drawingml/2006/main" w="0">
+            <a:solidFill>
+              <a:srgbClr val="000000">
+                <a:alpha val="0"/>
+              </a:srgbClr>
+            </a:solidFill>
+            <a:prstDash val="solid"/>
+          </a:ln>
+        </p:spPr>
+      </p:sp>
+      <p:sp>
+        <p:nvSpPr>
+          <p:cNvPr id="3" name="">
+            <a:extLst xmlns:a="http://schemas.openxmlformats.org/drawingml/2006/main">
+              <a:ext uri="{FF2B5EF4-FFF2-40B4-BE49-F238E27FC236}">
+                <a16:creationId xmlns:a16="http://schemas.microsoft.com/office/drawing/2014/main" id="{825FEE1C-4DBD-42E2-A4FB-6886641181AF}"/>
+              </a:ext>
+            </a:extLst>
+          </p:cNvPr>
+          <p:cNvSpPr>
+            <a:spLocks xmlns:a="http://schemas.openxmlformats.org/drawingml/2006/main" noGrp="1"/>
+          </p:cNvSpPr>
+          <p:nvPr/>
+        </p:nvSpPr>
+        <p:spPr>
+          <a:xfrm xmlns:a="http://schemas.openxmlformats.org/drawingml/2006/main">
+            <a:off x="533400" y="285750"/>
+            <a:ext cx="8096250" cy="228600"/>
+          </a:xfrm>
+          <a:prstGeom xmlns:a="http://schemas.openxmlformats.org/drawingml/2006/main" prst="rect">
+            <a:avLst/>
+          </a:prstGeom>
+          <a:solidFill xmlns:a="http://schemas.openxmlformats.org/drawingml/2006/main">
+            <a:srgbClr val="000000">
+              <a:alpha val="0"/>
+            </a:srgbClr>
+          </a:solidFill>
+          <a:ln xmlns:a="http://schemas.openxmlformats.org/drawingml/2006/main" w="0">
+            <a:solidFill>
+              <a:srgbClr val="000000">
+                <a:alpha val="0"/>
+              </a:srgbClr>
+            </a:solidFill>
+            <a:prstDash val="solid"/>
+          </a:ln>
+        </p:spPr>
+        <p:txBody>
+          <a:bodyPr xmlns:a="http://schemas.openxmlformats.org/drawingml/2006/main" lIns="0" tIns="0" rIns="0" bIns="0" anchor="t"/>
+          <a:lstStyle xmlns:a="http://schemas.openxmlformats.org/drawingml/2006/main"/>
+          <a:p xmlns:a="http://schemas.openxmlformats.org/drawingml/2006/main">
+            <a:pPr algn="l">
+              <a:buNone/>
+              <a:defRPr sz="1125" b="1">
+                <a:solidFill>
+                  <a:srgbClr val="2563EB"/>
+                </a:solidFill>
+                <a:latin typeface="Aptos"/>
+                <a:ea typeface="Aptos"/>
+                <a:cs typeface="Aptos"/>
+              </a:defRPr>
+            </a:pPr>
+            <a:r>
+              <a:rPr sz="1125" b="1">
+                <a:solidFill>
+                  <a:srgbClr val="2563EB"/>
+                </a:solidFill>
+                <a:latin typeface="Aptos"/>
+                <a:ea typeface="Aptos"/>
+                <a:cs typeface="Aptos"/>
+              </a:rPr>
+              <a:t>FACULTATIVE-AEROBE V2 INCREASED-PROFILE SIGNAL</a:t>
+            </a:r>
+          </a:p>
+        </p:txBody>
+      </p:sp>
+      <p:sp>
+        <p:nvSpPr>
+          <p:cNvPr id="4" name="">
+            <a:extLst xmlns:a="http://schemas.openxmlformats.org/drawingml/2006/main">
+              <a:ext uri="{FF2B5EF4-FFF2-40B4-BE49-F238E27FC236}">
+                <a16:creationId xmlns:a16="http://schemas.microsoft.com/office/drawing/2014/main" id="{2A60DE56-A194-4B6C-AD58-5F772E5859D8}"/>
+              </a:ext>
+            </a:extLst>
+          </p:cNvPr>
+          <p:cNvSpPr>
+            <a:spLocks xmlns:a="http://schemas.openxmlformats.org/drawingml/2006/main" noGrp="1"/>
+          </p:cNvSpPr>
+          <p:nvPr/>
+        </p:nvSpPr>
+        <p:spPr>
+          <a:xfrm xmlns:a="http://schemas.openxmlformats.org/drawingml/2006/main">
+            <a:off x="533400" y="552450"/>
+            <a:ext cx="10096500" cy="419100"/>
+          </a:xfrm>
+          <a:prstGeom xmlns:a="http://schemas.openxmlformats.org/drawingml/2006/main" prst="rect">
+            <a:avLst/>
+          </a:prstGeom>
+          <a:solidFill xmlns:a="http://schemas.openxmlformats.org/drawingml/2006/main">
+            <a:srgbClr val="000000">
+              <a:alpha val="0"/>
+            </a:srgbClr>
+          </a:solidFill>
+          <a:ln xmlns:a="http://schemas.openxmlformats.org/drawingml/2006/main" w="0">
+            <a:solidFill>
+              <a:srgbClr val="000000">
+                <a:alpha val="0"/>
+              </a:srgbClr>
+            </a:solidFill>
+            <a:prstDash val="solid"/>
+          </a:ln>
+        </p:spPr>
+        <p:txBody>
+          <a:bodyPr xmlns:a="http://schemas.openxmlformats.org/drawingml/2006/main" lIns="0" tIns="0" rIns="0" bIns="0" anchor="t"/>
+          <a:lstStyle xmlns:a="http://schemas.openxmlformats.org/drawingml/2006/main"/>
+          <a:p xmlns:a="http://schemas.openxmlformats.org/drawingml/2006/main">
+            <a:pPr algn="l">
+              <a:buNone/>
+              <a:defRPr sz="2025" b="1">
+                <a:solidFill>
+                  <a:srgbClr val="0F172A"/>
+                </a:solidFill>
+                <a:latin typeface="Aptos Display"/>
+                <a:ea typeface="Aptos Display"/>
+                <a:cs typeface="Aptos Display"/>
+              </a:defRPr>
+            </a:pPr>
+            <a:r>
+              <a:rPr sz="2025" b="1">
+                <a:solidFill>
+                  <a:srgbClr val="0F172A"/>
+                </a:solidFill>
+                <a:latin typeface="Aptos Display"/>
+                <a:ea typeface="Aptos Display"/>
+                <a:cs typeface="Aptos Display"/>
+              </a:rPr>
+              <a:t>Stacked focal taxa by increased-profile condition</a:t>
+            </a:r>
+          </a:p>
+        </p:txBody>
+      </p:sp>
+      <p:sp>
+        <p:nvSpPr>
+          <p:cNvPr id="5" name="">
+            <a:extLst xmlns:a="http://schemas.openxmlformats.org/drawingml/2006/main">
+              <a:ext uri="{FF2B5EF4-FFF2-40B4-BE49-F238E27FC236}">
+                <a16:creationId xmlns:a16="http://schemas.microsoft.com/office/drawing/2014/main" id="{72C49D0E-814C-47E1-88F7-F7C607DD57EC}"/>
+              </a:ext>
+            </a:extLst>
+          </p:cNvPr>
+          <p:cNvSpPr>
+            <a:spLocks xmlns:a="http://schemas.openxmlformats.org/drawingml/2006/main" noGrp="1"/>
+          </p:cNvSpPr>
+          <p:nvPr/>
+        </p:nvSpPr>
+        <p:spPr>
+          <a:xfrm xmlns:a="http://schemas.openxmlformats.org/drawingml/2006/main">
+            <a:off x="514350" y="1085850"/>
+            <a:ext cx="11125200" cy="5581650"/>
+          </a:xfrm>
+          <a:prstGeom xmlns:a="http://schemas.openxmlformats.org/drawingml/2006/main" prst="rect">
+            <a:avLst/>
+          </a:prstGeom>
+          <a:solidFill xmlns:a="http://schemas.openxmlformats.org/drawingml/2006/main">
+            <a:srgbClr val="FFFFFF"/>
+          </a:solidFill>
+          <a:ln xmlns:a="http://schemas.openxmlformats.org/drawingml/2006/main" w="9525">
+            <a:solidFill>
+              <a:srgbClr val="CBD5E1"/>
+            </a:solidFill>
+            <a:prstDash val="solid"/>
+          </a:ln>
+        </p:spPr>
+      </p:sp>
+      <p:pic>
+        <p:nvPicPr>
+          <p:cNvPr id="14" name="target_taxa_condition_breakdown_bar"/>
+          <p:cNvPicPr>
+            <a:picLocks xmlns:a="http://schemas.openxmlformats.org/drawingml/2006/main" noChangeAspect="1"/>
+          </p:cNvPicPr>
+          <p:nvPr/>
+        </p:nvPicPr>
+        <p:blipFill>
+          <a:blip xmlns:r="http://schemas.openxmlformats.org/officeDocument/2006/relationships" xmlns:a="http://schemas.openxmlformats.org/drawingml/2006/main" r:embed="R33cebe98bbc949aa"/>
+          <a:stretch xmlns:a="http://schemas.openxmlformats.org/drawingml/2006/main"/>
+        </p:blipFill>
+        <p:spPr>
+          <a:xfrm xmlns:a="http://schemas.openxmlformats.org/drawingml/2006/main" flipH="0" flipV="0">
+            <a:off x="2306193" y="1200162"/>
+            <a:ext cx="7579614" cy="5314927"/>
+          </a:xfrm>
+          <a:prstGeom xmlns:a="http://schemas.openxmlformats.org/drawingml/2006/main" prst="rect">
+            <a:avLst/>
+          </a:prstGeom>
+        </p:spPr>
+      </p:pic>
+      <p:sp>
+        <p:nvSpPr>
+          <p:cNvPr id="7" name="">
+            <a:extLst xmlns:a="http://schemas.openxmlformats.org/drawingml/2006/main">
+              <a:ext uri="{FF2B5EF4-FFF2-40B4-BE49-F238E27FC236}">
+                <a16:creationId xmlns:a16="http://schemas.microsoft.com/office/drawing/2014/main" id="{24AC0443-C24E-407E-A55A-56CA8B51484E}"/>
+              </a:ext>
+            </a:extLst>
+          </p:cNvPr>
+          <p:cNvSpPr>
+            <a:spLocks xmlns:a="http://schemas.openxmlformats.org/drawingml/2006/main" noGrp="1"/>
+          </p:cNvSpPr>
+          <p:nvPr/>
+        </p:nvSpPr>
+        <p:spPr>
+          <a:xfrm xmlns:a="http://schemas.openxmlformats.org/drawingml/2006/main">
+            <a:off x="11144250" y="314325"/>
+            <a:ext cx="609600" cy="190500"/>
+          </a:xfrm>
+          <a:prstGeom xmlns:a="http://schemas.openxmlformats.org/drawingml/2006/main" prst="rect">
+            <a:avLst/>
+          </a:prstGeom>
+          <a:solidFill xmlns:a="http://schemas.openxmlformats.org/drawingml/2006/main">
+            <a:srgbClr val="000000">
+              <a:alpha val="0"/>
+            </a:srgbClr>
+          </a:solidFill>
+          <a:ln xmlns:a="http://schemas.openxmlformats.org/drawingml/2006/main" w="0">
+            <a:solidFill>
+              <a:srgbClr val="000000">
+                <a:alpha val="0"/>
+              </a:srgbClr>
+            </a:solidFill>
+            <a:prstDash val="solid"/>
+          </a:ln>
+        </p:spPr>
+        <p:txBody>
+          <a:bodyPr xmlns:a="http://schemas.openxmlformats.org/drawingml/2006/main" lIns="0" tIns="0" rIns="0" bIns="0" anchor="t"/>
+          <a:lstStyle xmlns:a="http://schemas.openxmlformats.org/drawingml/2006/main"/>
+          <a:p xmlns:a="http://schemas.openxmlformats.org/drawingml/2006/main">
+            <a:pPr algn="r">
+              <a:buNone/>
+              <a:defRPr sz="975" b="0">
+                <a:solidFill>
+                  <a:srgbClr val="64748B"/>
+                </a:solidFill>
+                <a:latin typeface="Aptos"/>
+                <a:ea typeface="Aptos"/>
+                <a:cs typeface="Aptos"/>
+              </a:defRPr>
+            </a:pPr>
+            <a:r>
+              <a:rPr sz="975" b="0">
+                <a:solidFill>
+                  <a:srgbClr val="64748B"/>
+                </a:solidFill>
+                <a:latin typeface="Aptos"/>
+                <a:ea typeface="Aptos"/>
+                <a:cs typeface="Aptos"/>
+              </a:rPr>
+              <a:t>6/13</a:t>
+            </a:r>
+          </a:p>
+        </p:txBody>
+      </p:sp>
+    </p:spTree>
+    <p:extLst>
+      <p:ext uri="{BB962C8B-B14F-4D97-AF65-F5344CB8AC3E}">
+        <p14:creationId xmlns:p14="http://schemas.microsoft.com/office/powerpoint/2010/main" val="1514746578"/>
+      </p:ext>
+    </p:extLst>
+  </p:cSld>
+</p:sld>
+</file>
+
+<file path=ppt/slides/slide13.xml><?xml version="1.0" encoding="utf-8"?>
+<p:sld xmlns:p="http://schemas.openxmlformats.org/presentationml/2006/main">
+  <p:cSld>
+    <p:spTree>
+      <p:nvGrpSpPr>
+        <p:cNvPr id="1" name=""/>
+        <p:cNvGrpSpPr/>
+        <p:nvPr/>
+      </p:nvGrpSpPr>
+      <p:grpSpPr>
+        <a:xfrm xmlns:a="http://schemas.openxmlformats.org/drawingml/2006/main"/>
+      </p:grpSpPr>
+      <p:sp>
+        <p:nvSpPr>
+          <p:cNvPr id="1" name="">
+            <a:extLst xmlns:a="http://schemas.openxmlformats.org/drawingml/2006/main">
+              <a:ext uri="{FF2B5EF4-FFF2-40B4-BE49-F238E27FC236}">
+                <a16:creationId xmlns:a16="http://schemas.microsoft.com/office/drawing/2014/main" id="{44122360-870E-4939-ADEB-124952C58B0C}"/>
+              </a:ext>
+            </a:extLst>
+          </p:cNvPr>
+          <p:cNvSpPr>
+            <a:spLocks xmlns:a="http://schemas.openxmlformats.org/drawingml/2006/main" noGrp="1"/>
+          </p:cNvSpPr>
+          <p:nvPr/>
+        </p:nvSpPr>
+        <p:spPr>
+          <a:xfrm xmlns:a="http://schemas.openxmlformats.org/drawingml/2006/main">
+            <a:off x="0" y="0"/>
+            <a:ext cx="12192000" cy="6858000"/>
+          </a:xfrm>
+          <a:prstGeom xmlns:a="http://schemas.openxmlformats.org/drawingml/2006/main" prst="rect">
+            <a:avLst/>
+          </a:prstGeom>
+          <a:solidFill xmlns:a="http://schemas.openxmlformats.org/drawingml/2006/main">
+            <a:srgbClr val="F8FAFC"/>
+          </a:solidFill>
+          <a:ln xmlns:a="http://schemas.openxmlformats.org/drawingml/2006/main" w="0">
+            <a:solidFill>
+              <a:srgbClr val="000000">
+                <a:alpha val="0"/>
+              </a:srgbClr>
+            </a:solidFill>
+            <a:prstDash val="solid"/>
+          </a:ln>
+        </p:spPr>
+      </p:sp>
+      <p:sp>
+        <p:nvSpPr>
+          <p:cNvPr id="2" name="">
+            <a:extLst xmlns:a="http://schemas.openxmlformats.org/drawingml/2006/main">
+              <a:ext uri="{FF2B5EF4-FFF2-40B4-BE49-F238E27FC236}">
+                <a16:creationId xmlns:a16="http://schemas.microsoft.com/office/drawing/2014/main" id="{B545B818-E3A2-4B76-9E95-88CB5FD48514}"/>
+              </a:ext>
+            </a:extLst>
+          </p:cNvPr>
+          <p:cNvSpPr>
+            <a:spLocks xmlns:a="http://schemas.openxmlformats.org/drawingml/2006/main" noGrp="1"/>
+          </p:cNvSpPr>
+          <p:nvPr/>
+        </p:nvSpPr>
+        <p:spPr>
+          <a:xfrm xmlns:a="http://schemas.openxmlformats.org/drawingml/2006/main">
+            <a:off x="0" y="0"/>
+            <a:ext cx="12192000" cy="57150"/>
+          </a:xfrm>
+          <a:prstGeom xmlns:a="http://schemas.openxmlformats.org/drawingml/2006/main" prst="rect">
+            <a:avLst/>
+          </a:prstGeom>
+          <a:solidFill xmlns:a="http://schemas.openxmlformats.org/drawingml/2006/main">
+            <a:srgbClr val="0F766E"/>
+          </a:solidFill>
+          <a:ln xmlns:a="http://schemas.openxmlformats.org/drawingml/2006/main" w="0">
+            <a:solidFill>
+              <a:srgbClr val="000000">
+                <a:alpha val="0"/>
+              </a:srgbClr>
+            </a:solidFill>
+            <a:prstDash val="solid"/>
+          </a:ln>
+        </p:spPr>
+      </p:sp>
+      <p:sp>
+        <p:nvSpPr>
+          <p:cNvPr id="3" name="">
+            <a:extLst xmlns:a="http://schemas.openxmlformats.org/drawingml/2006/main">
+              <a:ext uri="{FF2B5EF4-FFF2-40B4-BE49-F238E27FC236}">
+                <a16:creationId xmlns:a16="http://schemas.microsoft.com/office/drawing/2014/main" id="{7B93629C-7C9C-4387-8F98-1A31CAF2F54A}"/>
+              </a:ext>
+            </a:extLst>
+          </p:cNvPr>
+          <p:cNvSpPr>
+            <a:spLocks xmlns:a="http://schemas.openxmlformats.org/drawingml/2006/main" noGrp="1"/>
+          </p:cNvSpPr>
+          <p:nvPr/>
+        </p:nvSpPr>
+        <p:spPr>
+          <a:xfrm xmlns:a="http://schemas.openxmlformats.org/drawingml/2006/main">
+            <a:off x="533400" y="285750"/>
+            <a:ext cx="8096250" cy="228600"/>
+          </a:xfrm>
+          <a:prstGeom xmlns:a="http://schemas.openxmlformats.org/drawingml/2006/main" prst="rect">
+            <a:avLst/>
+          </a:prstGeom>
+          <a:solidFill xmlns:a="http://schemas.openxmlformats.org/drawingml/2006/main">
+            <a:srgbClr val="000000">
+              <a:alpha val="0"/>
+            </a:srgbClr>
+          </a:solidFill>
+          <a:ln xmlns:a="http://schemas.openxmlformats.org/drawingml/2006/main" w="0">
+            <a:solidFill>
+              <a:srgbClr val="000000">
+                <a:alpha val="0"/>
+              </a:srgbClr>
+            </a:solidFill>
+            <a:prstDash val="solid"/>
+          </a:ln>
+        </p:spPr>
+        <p:txBody>
+          <a:bodyPr xmlns:a="http://schemas.openxmlformats.org/drawingml/2006/main" lIns="0" tIns="0" rIns="0" bIns="0" anchor="t"/>
+          <a:lstStyle xmlns:a="http://schemas.openxmlformats.org/drawingml/2006/main"/>
+          <a:p xmlns:a="http://schemas.openxmlformats.org/drawingml/2006/main">
+            <a:pPr algn="l">
+              <a:buNone/>
+              <a:defRPr sz="1125" b="1">
+                <a:solidFill>
+                  <a:srgbClr val="0F766E"/>
+                </a:solidFill>
+                <a:latin typeface="Aptos"/>
+                <a:ea typeface="Aptos"/>
+                <a:cs typeface="Aptos"/>
+              </a:defRPr>
+            </a:pPr>
+            <a:r>
+              <a:rPr sz="1125" b="1">
+                <a:solidFill>
+                  <a:srgbClr val="0F766E"/>
+                </a:solidFill>
+                <a:latin typeface="Aptos"/>
+                <a:ea typeface="Aptos"/>
+                <a:cs typeface="Aptos"/>
+              </a:rPr>
+              <a:t>ANAEROBE V2 DEPLETION SIGNAL</a:t>
+            </a:r>
+          </a:p>
+        </p:txBody>
+      </p:sp>
+      <p:sp>
+        <p:nvSpPr>
+          <p:cNvPr id="4" name="">
+            <a:extLst xmlns:a="http://schemas.openxmlformats.org/drawingml/2006/main">
+              <a:ext uri="{FF2B5EF4-FFF2-40B4-BE49-F238E27FC236}">
+                <a16:creationId xmlns:a16="http://schemas.microsoft.com/office/drawing/2014/main" id="{E512A9B8-49F5-4765-9F42-15922FE7941A}"/>
+              </a:ext>
+            </a:extLst>
+          </p:cNvPr>
+          <p:cNvSpPr>
+            <a:spLocks xmlns:a="http://schemas.openxmlformats.org/drawingml/2006/main" noGrp="1"/>
+          </p:cNvSpPr>
+          <p:nvPr/>
+        </p:nvSpPr>
+        <p:spPr>
+          <a:xfrm xmlns:a="http://schemas.openxmlformats.org/drawingml/2006/main">
+            <a:off x="533400" y="552450"/>
+            <a:ext cx="10096500" cy="419100"/>
+          </a:xfrm>
+          <a:prstGeom xmlns:a="http://schemas.openxmlformats.org/drawingml/2006/main" prst="rect">
+            <a:avLst/>
+          </a:prstGeom>
+          <a:solidFill xmlns:a="http://schemas.openxmlformats.org/drawingml/2006/main">
+            <a:srgbClr val="000000">
+              <a:alpha val="0"/>
+            </a:srgbClr>
+          </a:solidFill>
+          <a:ln xmlns:a="http://schemas.openxmlformats.org/drawingml/2006/main" w="0">
+            <a:solidFill>
+              <a:srgbClr val="000000">
+                <a:alpha val="0"/>
+              </a:srgbClr>
+            </a:solidFill>
+            <a:prstDash val="solid"/>
+          </a:ln>
+        </p:spPr>
+        <p:txBody>
+          <a:bodyPr xmlns:a="http://schemas.openxmlformats.org/drawingml/2006/main" lIns="0" tIns="0" rIns="0" bIns="0" anchor="t"/>
+          <a:lstStyle xmlns:a="http://schemas.openxmlformats.org/drawingml/2006/main"/>
+          <a:p xmlns:a="http://schemas.openxmlformats.org/drawingml/2006/main">
+            <a:pPr algn="l">
+              <a:buNone/>
+              <a:defRPr sz="2025" b="1">
+                <a:solidFill>
+                  <a:srgbClr val="0F172A"/>
+                </a:solidFill>
+                <a:latin typeface="Aptos Display"/>
+                <a:ea typeface="Aptos Display"/>
+                <a:cs typeface="Aptos Display"/>
+              </a:defRPr>
+            </a:pPr>
+            <a:r>
+              <a:rPr sz="2025" b="1">
+                <a:solidFill>
+                  <a:srgbClr val="0F172A"/>
+                </a:solidFill>
+                <a:latin typeface="Aptos Display"/>
+                <a:ea typeface="Aptos Display"/>
+                <a:cs typeface="Aptos Display"/>
+              </a:rPr>
+              <a:t>Stacked focal taxa by decreased-profile condition</a:t>
+            </a:r>
+          </a:p>
+        </p:txBody>
+      </p:sp>
+      <p:sp>
+        <p:nvSpPr>
+          <p:cNvPr id="5" name="">
+            <a:extLst xmlns:a="http://schemas.openxmlformats.org/drawingml/2006/main">
+              <a:ext uri="{FF2B5EF4-FFF2-40B4-BE49-F238E27FC236}">
+                <a16:creationId xmlns:a16="http://schemas.microsoft.com/office/drawing/2014/main" id="{B2358CAC-9A41-45C9-AC20-4C2425594090}"/>
+              </a:ext>
+            </a:extLst>
+          </p:cNvPr>
+          <p:cNvSpPr>
+            <a:spLocks xmlns:a="http://schemas.openxmlformats.org/drawingml/2006/main" noGrp="1"/>
+          </p:cNvSpPr>
+          <p:nvPr/>
+        </p:nvSpPr>
+        <p:spPr>
+          <a:xfrm xmlns:a="http://schemas.openxmlformats.org/drawingml/2006/main">
+            <a:off x="514350" y="1085850"/>
+            <a:ext cx="11125200" cy="5581650"/>
+          </a:xfrm>
+          <a:prstGeom xmlns:a="http://schemas.openxmlformats.org/drawingml/2006/main" prst="rect">
+            <a:avLst/>
+          </a:prstGeom>
+          <a:solidFill xmlns:a="http://schemas.openxmlformats.org/drawingml/2006/main">
+            <a:srgbClr val="FFFFFF"/>
+          </a:solidFill>
+          <a:ln xmlns:a="http://schemas.openxmlformats.org/drawingml/2006/main" w="9525">
+            <a:solidFill>
+              <a:srgbClr val="CBD5E1"/>
+            </a:solidFill>
+            <a:prstDash val="solid"/>
+          </a:ln>
+        </p:spPr>
+      </p:sp>
+      <p:pic>
+        <p:nvPicPr>
+          <p:cNvPr id="14" name="target_taxa_condition_breakdown_bar"/>
+          <p:cNvPicPr>
+            <a:picLocks xmlns:a="http://schemas.openxmlformats.org/drawingml/2006/main" noChangeAspect="1"/>
+          </p:cNvPicPr>
+          <p:nvPr/>
+        </p:nvPicPr>
+        <p:blipFill>
+          <a:blip xmlns:r="http://schemas.openxmlformats.org/officeDocument/2006/relationships" xmlns:a="http://schemas.openxmlformats.org/drawingml/2006/main" r:embed="R4f0b484d8d75453e"/>
+          <a:stretch xmlns:a="http://schemas.openxmlformats.org/drawingml/2006/main"/>
+        </p:blipFill>
+        <p:spPr>
+          <a:xfrm xmlns:a="http://schemas.openxmlformats.org/drawingml/2006/main" flipH="0" flipV="0">
+            <a:off x="2304308" y="1200150"/>
+            <a:ext cx="7583479" cy="5314950"/>
+          </a:xfrm>
+          <a:prstGeom xmlns:a="http://schemas.openxmlformats.org/drawingml/2006/main" prst="rect">
+            <a:avLst/>
+          </a:prstGeom>
+        </p:spPr>
+      </p:pic>
+      <p:sp>
+        <p:nvSpPr>
+          <p:cNvPr id="7" name="">
+            <a:extLst xmlns:a="http://schemas.openxmlformats.org/drawingml/2006/main">
+              <a:ext uri="{FF2B5EF4-FFF2-40B4-BE49-F238E27FC236}">
+                <a16:creationId xmlns:a16="http://schemas.microsoft.com/office/drawing/2014/main" id="{1EE7BDF5-35DB-4BFE-AB66-05685BC2A036}"/>
+              </a:ext>
+            </a:extLst>
+          </p:cNvPr>
+          <p:cNvSpPr>
+            <a:spLocks xmlns:a="http://schemas.openxmlformats.org/drawingml/2006/main" noGrp="1"/>
+          </p:cNvSpPr>
+          <p:nvPr/>
+        </p:nvSpPr>
+        <p:spPr>
+          <a:xfrm xmlns:a="http://schemas.openxmlformats.org/drawingml/2006/main">
+            <a:off x="11144250" y="314325"/>
+            <a:ext cx="609600" cy="190500"/>
+          </a:xfrm>
+          <a:prstGeom xmlns:a="http://schemas.openxmlformats.org/drawingml/2006/main" prst="rect">
+            <a:avLst/>
+          </a:prstGeom>
+          <a:solidFill xmlns:a="http://schemas.openxmlformats.org/drawingml/2006/main">
+            <a:srgbClr val="000000">
+              <a:alpha val="0"/>
+            </a:srgbClr>
+          </a:solidFill>
+          <a:ln xmlns:a="http://schemas.openxmlformats.org/drawingml/2006/main" w="0">
+            <a:solidFill>
+              <a:srgbClr val="000000">
+                <a:alpha val="0"/>
+              </a:srgbClr>
+            </a:solidFill>
+            <a:prstDash val="solid"/>
+          </a:ln>
+        </p:spPr>
+        <p:txBody>
+          <a:bodyPr xmlns:a="http://schemas.openxmlformats.org/drawingml/2006/main" lIns="0" tIns="0" rIns="0" bIns="0" anchor="t"/>
+          <a:lstStyle xmlns:a="http://schemas.openxmlformats.org/drawingml/2006/main"/>
+          <a:p xmlns:a="http://schemas.openxmlformats.org/drawingml/2006/main">
+            <a:pPr algn="r">
+              <a:buNone/>
+              <a:defRPr sz="975" b="0">
+                <a:solidFill>
+                  <a:srgbClr val="64748B"/>
+                </a:solidFill>
+                <a:latin typeface="Aptos"/>
+                <a:ea typeface="Aptos"/>
+                <a:cs typeface="Aptos"/>
+              </a:defRPr>
+            </a:pPr>
+            <a:r>
+              <a:rPr sz="975" b="0">
+                <a:solidFill>
+                  <a:srgbClr val="64748B"/>
+                </a:solidFill>
+                <a:latin typeface="Aptos"/>
+                <a:ea typeface="Aptos"/>
+                <a:cs typeface="Aptos"/>
+              </a:rPr>
+              <a:t>12/13</a:t>
+            </a:r>
+          </a:p>
+        </p:txBody>
+      </p:sp>
+    </p:spTree>
+    <p:extLst>
+      <p:ext uri="{BB962C8B-B14F-4D97-AF65-F5344CB8AC3E}">
+        <p14:creationId xmlns:p14="http://schemas.microsoft.com/office/powerpoint/2010/main" val="1270552470"/>
       </p:ext>
     </p:extLst>
   </p:cSld>
@@ -3009,7 +3695,7 @@
                 <a:ea typeface="Aptos"/>
                 <a:cs typeface="Aptos"/>
               </a:rPr>
-              <a:t>2/11</a:t>
+              <a:t>2/13</a:t>
             </a:r>
           </a:p>
         </p:txBody>
@@ -3351,7 +4037,7 @@
                 <a:ea typeface="Aptos"/>
                 <a:cs typeface="Aptos"/>
               </a:rPr>
-              <a:t>3/11</a:t>
+              <a:t>3/13</a:t>
             </a:r>
           </a:p>
         </p:txBody>
@@ -3693,7 +4379,7 @@
                 <a:ea typeface="Aptos"/>
                 <a:cs typeface="Aptos"/>
               </a:rPr>
-              <a:t>4/11</a:t>
+              <a:t>4/13</a:t>
             </a:r>
           </a:p>
         </p:txBody>
@@ -4035,7 +4721,7 @@
                 <a:ea typeface="Aptos"/>
                 <a:cs typeface="Aptos"/>
               </a:rPr>
-              <a:t>5/11</a:t>
+              <a:t>5/13</a:t>
             </a:r>
           </a:p>
         </p:txBody>
@@ -4377,7 +5063,7 @@
                 <a:ea typeface="Aptos"/>
                 <a:cs typeface="Aptos"/>
               </a:rPr>
-              <a:t>6/11</a:t>
+              <a:t>7/13</a:t>
             </a:r>
           </a:p>
         </p:txBody>
@@ -4719,7 +5405,7 @@
                 <a:ea typeface="Aptos"/>
                 <a:cs typeface="Aptos"/>
               </a:rPr>
-              <a:t>7/11</a:t>
+              <a:t>8/13</a:t>
             </a:r>
           </a:p>
         </p:txBody>
@@ -5061,7 +5747,7 @@
                 <a:ea typeface="Aptos"/>
                 <a:cs typeface="Aptos"/>
               </a:rPr>
-              <a:t>8/11</a:t>
+              <a:t>9/13</a:t>
             </a:r>
           </a:p>
         </p:txBody>
@@ -5403,7 +6089,7 @@
                 <a:ea typeface="Aptos"/>
                 <a:cs typeface="Aptos"/>
               </a:rPr>
-              <a:t>9/11</a:t>
+              <a:t>10/13</a:t>
             </a:r>
           </a:p>
         </p:txBody>

</xml_diff>

<commit_message>
Standardize trait profile terminology
</commit_message>
<xml_diff>
--- a/trait-visualization/trait-profile-investigation/trait_profile_investigation_figures.pptx
+++ b/trait-visualization/trait-profile-investigation/trait_profile_investigation_figures.pptx
@@ -1,30 +1,30 @@
 
 <file path=ppt/presentation.xml><?xml version="1.0" encoding="utf-8"?>
-<p:presentation xmlns:ns2="http://schemas.openxmlformats.org/drawingml/2006/main" xmlns:p="http://schemas.openxmlformats.org/presentationml/2006/main" xmlns:r="http://schemas.openxmlformats.org/officeDocument/2006/relationships">
-  <p:sldMasterIdLst>
-    <p:sldMasterId id="2147483648" r:id="Rb644bd47756a421e"/>
-  </p:sldMasterIdLst>
-  <p:notesMasterIdLst>
-    <p:notesMasterId r:id="R3c8c9a1074a94934"/>
-  </p:notesMasterIdLst>
-  <p:sldIdLst>
-    <p:sldId id="256" r:id="Rbfc58da720d648da"/>
-    <p:sldId id="257" r:id="R8f2ac862138042e5"/>
-    <p:sldId id="258" r:id="Rd3b25f4c09ee47e2"/>
-    <p:sldId id="259" r:id="R3ea2429faee64daf"/>
-    <p:sldId id="260" r:id="Re6426ad2094948ee"/>
-    <p:sldId id="267" r:id="RfacultativeStackedTaxaSlide"/>
-    <p:sldId id="261" r:id="Rdef2e4d414e242ac"/>
-    <p:sldId id="262" r:id="Rb8186928d7da4ec3"/>
-    <p:sldId id="263" r:id="R008c946eb3ca4790"/>
-    <p:sldId id="264" r:id="Rf2e96244434c47c9"/>
-    <p:sldId id="265" r:id="R9f87991bfc724d2a"/>
-    <p:sldId id="268" r:id="RanaerobeStackedTaxaSlide"/>
-    <p:sldId id="266" r:id="R232fba94521d4791"/>
-  </p:sldIdLst>
-  <p:sldSz cx="12192000" cy="6858000"/>
-  <p:notesSz cx="6858000" cy="9144000"/>
-  <p:defaultTextStyle>
+<ns0:presentation xmlns:ns0="http://schemas.openxmlformats.org/presentationml/2006/main" xmlns:ns1="http://schemas.openxmlformats.org/officeDocument/2006/relationships" xmlns:ns2="http://schemas.openxmlformats.org/drawingml/2006/main">
+  <ns0:sldMasterIdLst>
+    <ns0:sldMasterId id="2147483648" ns1:id="Rb644bd47756a421e"/>
+  </ns0:sldMasterIdLst>
+  <ns0:notesMasterIdLst>
+    <ns0:notesMasterId ns1:id="R3c8c9a1074a94934"/>
+  </ns0:notesMasterIdLst>
+  <ns0:sldIdLst>
+    <ns0:sldId id="256" ns1:id="Rbfc58da720d648da"/>
+    <ns0:sldId id="257" ns1:id="R8f2ac862138042e5"/>
+    <ns0:sldId id="258" ns1:id="Rd3b25f4c09ee47e2"/>
+    <ns0:sldId id="259" ns1:id="R3ea2429faee64daf"/>
+    <ns0:sldId id="260" ns1:id="Re6426ad2094948ee"/>
+    <ns0:sldId id="267" ns1:id="RfacultativeStackedTaxaSlide"/>
+    <ns0:sldId id="261" ns1:id="Rdef2e4d414e242ac"/>
+    <ns0:sldId id="262" ns1:id="Rb8186928d7da4ec3"/>
+    <ns0:sldId id="263" ns1:id="R008c946eb3ca4790"/>
+    <ns0:sldId id="264" ns1:id="Rf2e96244434c47c9"/>
+    <ns0:sldId id="265" ns1:id="R9f87991bfc724d2a"/>
+    <ns0:sldId id="268" ns1:id="RanaerobeStackedTaxaSlide"/>
+    <ns0:sldId id="266" ns1:id="R232fba94521d4791"/>
+  </ns0:sldIdLst>
+  <ns0:sldSz cx="12192000" cy="6858000"/>
+  <ns0:notesSz cx="6858000" cy="9144000"/>
+  <ns0:defaultTextStyle>
     <ns2:defPPr>
       <ns2:defRPr lang="en-US"/>
     </ns2:defPPr>
@@ -118,8 +118,8 @@
         <ns2:cs typeface="+mn-cs"/>
       </ns2:defRPr>
     </ns2:lvl9pPr>
-  </p:defaultTextStyle>
-</p:presentation>
+  </ns0:defaultTextStyle>
+</ns0:presentation>
 </file>
 
 <file path=ppt/notesMasters/notesMaster1.xml><?xml version="1.0" encoding="utf-8"?>
@@ -2257,7 +2257,7 @@
                 <a:ea typeface="Aptos Display"/>
                 <a:cs typeface="Aptos Display"/>
               </a:rPr>
-              <a:t>Top conditions for decreased target-taxon occurrences</a:t>
+              <a:t>Top conditions for decreased-profile target-taxon occurrences</a:t>
             </a:r>
           </a:p>
         </p:txBody>
@@ -3575,7 +3575,7 @@
                 <a:ea typeface="Aptos Display"/>
                 <a:cs typeface="Aptos Display"/>
               </a:rPr>
-              <a:t>Conditions with high increased-profile v2 guild signal</a:t>
+              <a:t>Conditions with facultative-aerobe v2 trait enrichment in increased profiles</a:t>
             </a:r>
           </a:p>
         </p:txBody>
@@ -3917,7 +3917,7 @@
                 <a:ea typeface="Aptos Display"/>
                 <a:cs typeface="Aptos Display"/>
               </a:rPr>
-              <a:t>V2 guild traits are higher in increased profiles</a:t>
+              <a:t>V2 traits enriched in increased profiles</a:t>
             </a:r>
           </a:p>
         </p:txBody>
@@ -4259,7 +4259,7 @@
                 <a:ea typeface="Aptos Display"/>
                 <a:cs typeface="Aptos Display"/>
               </a:rPr>
-              <a:t>Anatomical sites for increased-profile facultative-aerobe v2 signal</a:t>
+              <a:t>Anatomical sites for facultative-aerobe v2 trait enrichment in increased profiles</a:t>
             </a:r>
           </a:p>
         </p:txBody>
@@ -4601,7 +4601,7 @@
                 <a:ea typeface="Aptos Display"/>
                 <a:cs typeface="Aptos Display"/>
               </a:rPr>
-              <a:t>Top conditions for increased target-taxon occurrences</a:t>
+              <a:t>Top conditions for increased-profile target-taxon occurrences</a:t>
             </a:r>
           </a:p>
         </p:txBody>
@@ -5285,7 +5285,7 @@
                 <a:ea typeface="Aptos Display"/>
                 <a:cs typeface="Aptos Display"/>
               </a:rPr>
-              <a:t>Conditions with high decreased-profile anaerobe v2 guild signal</a:t>
+              <a:t>Conditions with anaerobe v2 trait enrichment in decreased profiles</a:t>
             </a:r>
           </a:p>
         </p:txBody>
@@ -5627,7 +5627,7 @@
                 <a:ea typeface="Aptos Display"/>
                 <a:cs typeface="Aptos Display"/>
               </a:rPr>
-              <a:t>V2 guild traits are higher in decreased profiles</a:t>
+              <a:t>V2 traits enriched in decreased profiles</a:t>
             </a:r>
           </a:p>
         </p:txBody>
@@ -5969,7 +5969,7 @@
                 <a:ea typeface="Aptos Display"/>
                 <a:cs typeface="Aptos Display"/>
               </a:rPr>
-              <a:t>Anatomical sites for decreased-profile anaerobe v2 signal</a:t>
+              <a:t>Anatomical sites for anaerobe v2 trait enrichment in decreased profiles</a:t>
             </a:r>
           </a:p>
         </p:txBody>

</xml_diff>

<commit_message>
Update v3 Sankey diagrams and rollups
</commit_message>
<xml_diff>
--- a/trait-visualization/trait-profile-investigation/trait_profile_investigation_figures.pptx
+++ b/trait-visualization/trait-profile-investigation/trait_profile_investigation_figures.pptx
@@ -1850,7 +1850,7 @@
                 <a:ea typeface="Aptos"/>
                 <a:cs typeface="Aptos"/>
               </a:rPr>
-              <a:t>FACULTATIVE-AEROBE V2 INCREASED-PROFILE SIGNAL</a:t>
+              <a:t>AEROBE V2 TRAIT ENRICHMENT IN INCREASED PROFILES</a:t>
             </a:r>
           </a:p>
         </p:txBody>
@@ -2826,7 +2826,7 @@
                 <a:ea typeface="Aptos"/>
                 <a:cs typeface="Aptos"/>
               </a:rPr>
-              <a:t>FACULTATIVE-AEROBE V2 INCREASED-PROFILE SIGNAL</a:t>
+              <a:t>AEROBE V2 TRAIT ENRICHMENT IN INCREASED PROFILES</a:t>
             </a:r>
           </a:p>
         </p:txBody>
@@ -3510,7 +3510,7 @@
                 <a:ea typeface="Aptos"/>
                 <a:cs typeface="Aptos"/>
               </a:rPr>
-              <a:t>FACULTATIVE-AEROBE V2 INCREASED-PROFILE SIGNAL</a:t>
+              <a:t>AEROBE V2 TRAIT ENRICHMENT IN INCREASED PROFILES</a:t>
             </a:r>
           </a:p>
         </p:txBody>
@@ -3575,7 +3575,7 @@
                 <a:ea typeface="Aptos Display"/>
                 <a:cs typeface="Aptos Display"/>
               </a:rPr>
-              <a:t>Conditions with facultative-aerobe v2 trait enrichment in increased profiles</a:t>
+              <a:t>Conditions with aerobe v2 trait enrichment in increased profiles</a:t>
             </a:r>
           </a:p>
         </p:txBody>
@@ -3852,7 +3852,7 @@
                 <a:ea typeface="Aptos"/>
                 <a:cs typeface="Aptos"/>
               </a:rPr>
-              <a:t>FACULTATIVE-AEROBE V2 INCREASED-PROFILE SIGNAL</a:t>
+              <a:t>AEROBE V2 TRAIT ENRICHMENT IN INCREASED PROFILES</a:t>
             </a:r>
           </a:p>
         </p:txBody>
@@ -4194,7 +4194,7 @@
                 <a:ea typeface="Aptos"/>
                 <a:cs typeface="Aptos"/>
               </a:rPr>
-              <a:t>FACULTATIVE-AEROBE V2 INCREASED-PROFILE SIGNAL</a:t>
+              <a:t>AEROBE V2 TRAIT ENRICHMENT IN INCREASED PROFILES</a:t>
             </a:r>
           </a:p>
         </p:txBody>
@@ -4259,7 +4259,7 @@
                 <a:ea typeface="Aptos Display"/>
                 <a:cs typeface="Aptos Display"/>
               </a:rPr>
-              <a:t>Anatomical sites for facultative-aerobe v2 trait enrichment in increased profiles</a:t>
+              <a:t>Anatomical sites for aerobe v2 trait enrichment in increased profiles</a:t>
             </a:r>
           </a:p>
         </p:txBody>
@@ -4536,7 +4536,7 @@
                 <a:ea typeface="Aptos"/>
                 <a:cs typeface="Aptos"/>
               </a:rPr>
-              <a:t>FACULTATIVE-AEROBE V2 INCREASED-PROFILE SIGNAL</a:t>
+              <a:t>AEROBE V2 TRAIT ENRICHMENT IN INCREASED PROFILES</a:t>
             </a:r>
           </a:p>
         </p:txBody>

</xml_diff>